<commit_message>
Presentation: remove the gaps-and-objectives slide (18 slides) and update contents numbers
Co-Authored-By: Claude Sonnet 5.5 <noreply@anthropic.com>
Claude-Session: https://claude.ai/code/session_013CSadMbHd5eZzDnpHkiwuR
</commit_message>
<xml_diff>
--- a/presentation/SwarmFolio_Final_Presentation.pptx
+++ b/presentation/SwarmFolio_Final_Presentation.pptx
@@ -14,7 +14,6 @@
     <p:sldId id="265" r:id="rId5"/>
     <p:sldId id="274" r:id="rId20"/>
     <p:sldId id="266" r:id="rId6"/>
-    <p:sldId id="275" r:id="rId21"/>
     <p:sldId id="267" r:id="rId7"/>
     <p:sldId id="268" r:id="rId8"/>
     <p:sldId id="276" r:id="rId22"/>
@@ -3017,76 +3016,6 @@
           <a:p>
             <a:r>
               <a:t>Detailed survey in the required format: paper, venue, year, technique, limitation and the gap each leaves. The portfolio PSO papers use one scalarised objective, which is the gap our three-objective front addresses. Full references are in the report.</a:t>
-            </a:r>
-          </a:p>
-        </p:txBody>
-      </p:sp>
-      <p:sp>
-        <p:nvSpPr>
-          <p:cNvPr id="4" name="Slide Number Placeholder 3"/>
-          <p:cNvSpPr>
-            <a:spLocks noGrp="1"/>
-          </p:cNvSpPr>
-          <p:nvPr>
-            <p:ph type="sldNum" idx="5" sz="quarter"/>
-          </p:nvPr>
-        </p:nvSpPr>
-        <p:spPr/>
-      </p:sp>
-    </p:spTree>
-  </p:cSld>
-  <p:clrMapOvr>
-    <a:masterClrMapping/>
-  </p:clrMapOvr>
-</p:notes>
-</file>
-
-<file path=ppt/notesSlides/notesSlide7.xml><?xml version="1.0" encoding="utf-8"?>
-<p:notes xmlns:a="http://schemas.openxmlformats.org/drawingml/2006/main" xmlns:p="http://schemas.openxmlformats.org/presentationml/2006/main" xmlns:r="http://schemas.openxmlformats.org/officeDocument/2006/relationships">
-  <p:cSld>
-    <p:spTree>
-      <p:nvGrpSpPr>
-        <p:cNvPr id="1" name=""/>
-        <p:cNvGrpSpPr/>
-        <p:nvPr/>
-      </p:nvGrpSpPr>
-      <p:grpSpPr>
-        <a:xfrm>
-          <a:off x="0" y="0"/>
-          <a:ext cx="0" cy="0"/>
-          <a:chOff x="0" y="0"/>
-          <a:chExt cx="0" cy="0"/>
-        </a:xfrm>
-      </p:grpSpPr>
-      <p:sp>
-        <p:nvSpPr>
-          <p:cNvPr id="2" name="Slide Image Placeholder 1"/>
-          <p:cNvSpPr>
-            <a:spLocks noGrp="1"/>
-          </p:cNvSpPr>
-          <p:nvPr>
-            <p:ph type="sldImg" idx="2"/>
-          </p:nvPr>
-        </p:nvSpPr>
-        <p:spPr/>
-      </p:sp>
-      <p:sp>
-        <p:nvSpPr>
-          <p:cNvPr id="3" name="Notes Placeholder 2"/>
-          <p:cNvSpPr>
-            <a:spLocks noGrp="1"/>
-          </p:cNvSpPr>
-          <p:nvPr>
-            <p:ph type="body" idx="3" sz="quarter"/>
-          </p:nvPr>
-        </p:nvSpPr>
-        <p:spPr/>
-        <p:txBody>
-          <a:bodyPr/>
-          <a:lstStyle/>
-          <a:p>
-            <a:r>
-              <a:t>Research gap identification and the mapping of our objectives to those gaps. The claim is limited to the surveyed papers.</a:t>
             </a:r>
           </a:p>
         </p:txBody>
@@ -17229,7 +17158,7 @@
                 </a:solidFill>
                 <a:latin typeface="Calibri"/>
               </a:rPr>
-              <a:t>8</a:t>
+              <a:t>7</a:t>
             </a:r>
           </a:p>
         </p:txBody>
@@ -17365,7 +17294,7 @@
                 </a:solidFill>
                 <a:latin typeface="Calibri"/>
               </a:rPr>
-              <a:t>9</a:t>
+              <a:t>8</a:t>
             </a:r>
           </a:p>
         </p:txBody>
@@ -17501,7 +17430,7 @@
                 </a:solidFill>
                 <a:latin typeface="Calibri"/>
               </a:rPr>
-              <a:t>11</a:t>
+              <a:t>10</a:t>
             </a:r>
           </a:p>
         </p:txBody>
@@ -17637,7 +17566,7 @@
                 </a:solidFill>
                 <a:latin typeface="Calibri"/>
               </a:rPr>
-              <a:t>13</a:t>
+              <a:t>12</a:t>
             </a:r>
           </a:p>
         </p:txBody>
@@ -17773,7 +17702,7 @@
                 </a:solidFill>
                 <a:latin typeface="Calibri"/>
               </a:rPr>
-              <a:t>14</a:t>
+              <a:t>13</a:t>
             </a:r>
           </a:p>
         </p:txBody>
@@ -17909,7 +17838,7 @@
                 </a:solidFill>
                 <a:latin typeface="Calibri"/>
               </a:rPr>
-              <a:t>18</a:t>
+              <a:t>17</a:t>
             </a:r>
           </a:p>
         </p:txBody>
@@ -18045,7 +17974,7 @@
                 </a:solidFill>
                 <a:latin typeface="Calibri"/>
               </a:rPr>
-              <a:t>19</a:t>
+              <a:t>18</a:t>
             </a:r>
           </a:p>
         </p:txBody>
@@ -22395,900 +22324,6 @@
 </p:sld>
 </file>
 
-<file path=ppt/slides/slide7.xml><?xml version="1.0" encoding="utf-8"?>
-<p:sld xmlns:a="http://schemas.openxmlformats.org/drawingml/2006/main" xmlns:r="http://schemas.openxmlformats.org/officeDocument/2006/relationships" xmlns:p="http://schemas.openxmlformats.org/presentationml/2006/main">
-  <p:cSld>
-    <p:spTree>
-      <p:nvGrpSpPr>
-        <p:cNvPr id="1" name=""/>
-        <p:cNvGrpSpPr/>
-        <p:nvPr/>
-      </p:nvGrpSpPr>
-      <p:grpSpPr>
-        <a:xfrm>
-          <a:off x="0" y="0"/>
-          <a:ext cx="0" cy="0"/>
-          <a:chOff x="0" y="0"/>
-          <a:chExt cx="0" cy="0"/>
-        </a:xfrm>
-      </p:grpSpPr>
-      <p:sp>
-        <p:nvSpPr>
-          <p:cNvPr id="2" name="Title 1">
-            <a:extLst>
-              <a:ext uri="{FF2B5EF4-FFF2-40B4-BE49-F238E27FC236}">
-                <a16:creationId xmlns:a16="http://schemas.microsoft.com/office/drawing/2014/main" id="{BD1A189D-22D1-4D1A-9E04-C6134EC51F8B}"/>
-              </a:ext>
-            </a:extLst>
-          </p:cNvPr>
-          <p:cNvSpPr>
-            <a:spLocks noGrp="1"/>
-          </p:cNvSpPr>
-          <p:nvPr>
-            <p:ph type="ctrTitle"/>
-          </p:nvPr>
-        </p:nvSpPr>
-        <p:spPr>
-          <a:xfrm>
-            <a:off x="1684868" y="203198"/>
-            <a:ext cx="9694332" cy="880535"/>
-          </a:xfrm>
-        </p:spPr>
-        <p:txBody>
-          <a:bodyPr>
-            <a:noAutofit/>
-          </a:bodyPr>
-          <a:lstStyle/>
-          <a:p>
-            <a:r>
-              <a:rPr sz="3600"/>
-              <a:t>Literature Survey: gaps and our objectives</a:t>
-            </a:r>
-          </a:p>
-        </p:txBody>
-      </p:sp>
-      <p:pic>
-        <p:nvPicPr>
-          <p:cNvPr id="5" name="Graphic 4">
-            <a:extLst>
-              <a:ext uri="{FF2B5EF4-FFF2-40B4-BE49-F238E27FC236}">
-                <a16:creationId xmlns:a16="http://schemas.microsoft.com/office/drawing/2014/main" id="{E7125167-8301-4D88-B79A-A8DA3C19E0D6}"/>
-              </a:ext>
-            </a:extLst>
-          </p:cNvPr>
-          <p:cNvPicPr>
-            <a:picLocks noChangeAspect="1"/>
-          </p:cNvPicPr>
-          <p:nvPr/>
-        </p:nvPicPr>
-        <p:blipFill>
-          <a:blip r:embed="rId2">
-            <a:extLst>
-              <a:ext uri="{96DAC541-7B7A-43D3-8B79-37D633B846F1}">
-                <asvg:svgBlip xmlns:asvg="http://schemas.microsoft.com/office/drawing/2016/SVG/main" r:embed="rId3"/>
-              </a:ext>
-            </a:extLst>
-          </a:blip>
-          <a:stretch>
-            <a:fillRect/>
-          </a:stretch>
-        </p:blipFill>
-        <p:spPr>
-          <a:xfrm>
-            <a:off x="127001" y="86782"/>
-            <a:ext cx="1159932" cy="1159932"/>
-          </a:xfrm>
-          <a:prstGeom prst="rect">
-            <a:avLst/>
-          </a:prstGeom>
-        </p:spPr>
-      </p:pic>
-      <p:sp>
-        <p:nvSpPr>
-          <p:cNvPr id="4" name="Date Placeholder 3">
-            <a:extLst>
-              <a:ext uri="{FF2B5EF4-FFF2-40B4-BE49-F238E27FC236}">
-                <a16:creationId xmlns:a16="http://schemas.microsoft.com/office/drawing/2014/main" id="{35032362-C5A5-4DBF-AD79-DE6FB7439999}"/>
-              </a:ext>
-            </a:extLst>
-          </p:cNvPr>
-          <p:cNvSpPr>
-            <a:spLocks noGrp="1"/>
-          </p:cNvSpPr>
-          <p:nvPr>
-            <p:ph type="dt" sz="half" idx="10"/>
-          </p:nvPr>
-        </p:nvSpPr>
-        <p:spPr/>
-        <p:txBody>
-          <a:bodyPr/>
-          <a:lstStyle/>
-          <a:p>
-            <a:fld id="{64C96E34-94C0-49E4-A53B-4A44141FD3C8}" type="datetime3">
-              <a:rPr lang="en-US" smtClean="0"/>
-              <a:t>14 October 2026</a:t>
-            </a:fld>
-            <a:endParaRPr lang="en-US" dirty="0"/>
-          </a:p>
-        </p:txBody>
-      </p:sp>
-      <p:sp>
-        <p:nvSpPr>
-          <p:cNvPr id="6" name="Slide Number Placeholder 5">
-            <a:extLst>
-              <a:ext uri="{FF2B5EF4-FFF2-40B4-BE49-F238E27FC236}">
-                <a16:creationId xmlns:a16="http://schemas.microsoft.com/office/drawing/2014/main" id="{115AAB64-5B51-4B5A-B69E-D96362CE6E74}"/>
-              </a:ext>
-            </a:extLst>
-          </p:cNvPr>
-          <p:cNvSpPr>
-            <a:spLocks noGrp="1"/>
-          </p:cNvSpPr>
-          <p:nvPr>
-            <p:ph type="sldNum" sz="quarter" idx="12"/>
-          </p:nvPr>
-        </p:nvSpPr>
-        <p:spPr/>
-        <p:txBody>
-          <a:bodyPr/>
-          <a:lstStyle/>
-          <a:p>
-            <a:fld id="{D57F1E4F-1CFF-5643-939E-217C01CDF565}" type="slidenum">
-              <a:rPr lang="en-US" smtClean="0"/>
-              <a:pPr/>
-              <a:t>5</a:t>
-            </a:fld>
-            <a:endParaRPr lang="en-US" dirty="0"/>
-          </a:p>
-        </p:txBody>
-      </p:sp>
-      <p:sp>
-        <p:nvSpPr>
-          <p:cNvPr id="7" name="Footer Placeholder 6">
-            <a:extLst>
-              <a:ext uri="{FF2B5EF4-FFF2-40B4-BE49-F238E27FC236}">
-                <a16:creationId xmlns:a16="http://schemas.microsoft.com/office/drawing/2014/main" id="{8683C6DF-27D9-468B-A1AB-FE568488FE57}"/>
-              </a:ext>
-            </a:extLst>
-          </p:cNvPr>
-          <p:cNvSpPr>
-            <a:spLocks noGrp="1"/>
-          </p:cNvSpPr>
-          <p:nvPr>
-            <p:ph type="ftr" sz="quarter" idx="11"/>
-          </p:nvPr>
-        </p:nvSpPr>
-        <p:spPr/>
-        <p:txBody>
-          <a:bodyPr/>
-          <a:lstStyle/>
-          <a:p>
-            <a:r>
-              <a:rPr lang="en-US"/>
-              <a:t>Dept of AI &amp; DS</a:t>
-            </a:r>
-            <a:endParaRPr lang="en-US" dirty="0"/>
-          </a:p>
-        </p:txBody>
-      </p:sp>
-      <p:sp>
-        <p:nvSpPr>
-          <p:cNvPr id="8" name="TextBox 7"/>
-          <p:cNvSpPr txBox="1"/>
-          <p:nvPr/>
-        </p:nvSpPr>
-        <p:spPr>
-          <a:xfrm>
-            <a:off x="594360" y="1371600"/>
-            <a:ext cx="4937760" cy="365760"/>
-          </a:xfrm>
-          <a:prstGeom prst="rect">
-            <a:avLst/>
-          </a:prstGeom>
-          <a:noFill/>
-        </p:spPr>
-        <p:txBody>
-          <a:bodyPr wrap="square" lIns="45720" rIns="45720" tIns="27432" bIns="27432" anchor="t">
-            <a:noAutofit/>
-          </a:bodyPr>
-          <a:lstStyle/>
-          <a:p>
-            <a:pPr algn="l"/>
-            <a:r>
-              <a:rPr sz="1800" b="1" i="0">
-                <a:solidFill>
-                  <a:srgbClr val="2683C6"/>
-                </a:solidFill>
-                <a:latin typeface="Calibri"/>
-              </a:rPr>
-              <a:t>Research gap identified</a:t>
-            </a:r>
-          </a:p>
-        </p:txBody>
-      </p:sp>
-      <p:sp>
-        <p:nvSpPr>
-          <p:cNvPr id="9" name="TextBox 8"/>
-          <p:cNvSpPr txBox="1"/>
-          <p:nvPr/>
-        </p:nvSpPr>
-        <p:spPr>
-          <a:xfrm>
-            <a:off x="6720840" y="1371600"/>
-            <a:ext cx="4937760" cy="365760"/>
-          </a:xfrm>
-          <a:prstGeom prst="rect">
-            <a:avLst/>
-          </a:prstGeom>
-          <a:noFill/>
-        </p:spPr>
-        <p:txBody>
-          <a:bodyPr wrap="square" lIns="45720" rIns="45720" tIns="27432" bIns="27432" anchor="t">
-            <a:noAutofit/>
-          </a:bodyPr>
-          <a:lstStyle/>
-          <a:p>
-            <a:pPr algn="l"/>
-            <a:r>
-              <a:rPr sz="1800" b="1" i="0">
-                <a:solidFill>
-                  <a:srgbClr val="D9731A"/>
-                </a:solidFill>
-                <a:latin typeface="Calibri"/>
-              </a:rPr>
-              <a:t>Our objective that addresses it</a:t>
-            </a:r>
-          </a:p>
-        </p:txBody>
-      </p:sp>
-      <p:sp>
-        <p:nvSpPr>
-          <p:cNvPr id="10" name="Rounded Rectangle 9"/>
-          <p:cNvSpPr/>
-          <p:nvPr/>
-        </p:nvSpPr>
-        <p:spPr>
-          <a:xfrm>
-            <a:off x="594360" y="1874519"/>
-            <a:ext cx="5120640" cy="841248"/>
-          </a:xfrm>
-          <a:prstGeom prst="roundRect">
-            <a:avLst>
-              <a:gd name="adj" fmla="val 15000"/>
-            </a:avLst>
-          </a:prstGeom>
-          <a:solidFill>
-            <a:srgbClr val="EAF3FA"/>
-          </a:solidFill>
-          <a:ln>
-            <a:noFill/>
-          </a:ln>
-          <a:effectLst/>
-        </p:spPr>
-        <p:style>
-          <a:lnRef idx="1">
-            <a:schemeClr val="accent1"/>
-          </a:lnRef>
-          <a:fillRef idx="3">
-            <a:schemeClr val="accent1"/>
-          </a:fillRef>
-          <a:effectRef idx="2">
-            <a:schemeClr val="accent1"/>
-          </a:effectRef>
-          <a:fontRef idx="minor">
-            <a:schemeClr val="lt1"/>
-          </a:fontRef>
-        </p:style>
-        <p:txBody>
-          <a:bodyPr rtlCol="0" anchor="ctr" wrap="square" tIns="36576" bIns="36576">
-            <a:noAutofit/>
-          </a:bodyPr>
-          <a:lstStyle/>
-          <a:p>
-            <a:pPr algn="l"/>
-            <a:r>
-              <a:rPr sz="1600" b="0" i="0">
-                <a:solidFill>
-                  <a:srgbClr val="335B74"/>
-                </a:solidFill>
-                <a:latin typeface="Calibri"/>
-              </a:rPr>
-              <a:t>Held-out testing across many markets is rare</a:t>
-            </a:r>
-          </a:p>
-        </p:txBody>
-      </p:sp>
-      <p:sp>
-        <p:nvSpPr>
-          <p:cNvPr id="11" name="Rounded Rectangle 10"/>
-          <p:cNvSpPr/>
-          <p:nvPr/>
-        </p:nvSpPr>
-        <p:spPr>
-          <a:xfrm>
-            <a:off x="6492240" y="1874519"/>
-            <a:ext cx="5212080" cy="841248"/>
-          </a:xfrm>
-          <a:prstGeom prst="roundRect">
-            <a:avLst>
-              <a:gd name="adj" fmla="val 15000"/>
-            </a:avLst>
-          </a:prstGeom>
-          <a:solidFill>
-            <a:srgbClr val="FBEFE3"/>
-          </a:solidFill>
-          <a:ln>
-            <a:noFill/>
-          </a:ln>
-          <a:effectLst/>
-        </p:spPr>
-        <p:style>
-          <a:lnRef idx="1">
-            <a:schemeClr val="accent1"/>
-          </a:lnRef>
-          <a:fillRef idx="3">
-            <a:schemeClr val="accent1"/>
-          </a:fillRef>
-          <a:effectRef idx="2">
-            <a:schemeClr val="accent1"/>
-          </a:effectRef>
-          <a:fontRef idx="minor">
-            <a:schemeClr val="lt1"/>
-          </a:fontRef>
-        </p:style>
-        <p:txBody>
-          <a:bodyPr rtlCol="0" anchor="ctr" wrap="square" tIns="36576" bIns="36576">
-            <a:noAutofit/>
-          </a:bodyPr>
-          <a:lstStyle/>
-          <a:p>
-            <a:pPr algn="l"/>
-            <a:r>
-              <a:rPr sz="1600" b="0" i="0">
-                <a:solidFill>
-                  <a:srgbClr val="335B74"/>
-                </a:solidFill>
-                <a:latin typeface="Calibri"/>
-              </a:rPr>
-              <a:t>Test portfolios on 30 simulated markets with a paired test</a:t>
-            </a:r>
-          </a:p>
-        </p:txBody>
-      </p:sp>
-      <p:cxnSp>
-        <p:nvCxnSpPr>
-          <p:cNvPr id="12" name="Connector 11"/>
-          <p:cNvCxnSpPr/>
-          <p:nvPr/>
-        </p:nvCxnSpPr>
-        <p:spPr>
-          <a:xfrm>
-            <a:off x="5760720" y="2295144"/>
-            <a:ext cx="685800" cy="0"/>
-          </a:xfrm>
-          <a:prstGeom prst="line">
-            <a:avLst/>
-          </a:prstGeom>
-          <a:ln w="22225">
-            <a:solidFill>
-              <a:srgbClr val="335B74"/>
-            </a:solidFill>
-            <a:tailEnd type="triangle"/>
-          </a:ln>
-        </p:spPr>
-        <p:style>
-          <a:lnRef idx="2">
-            <a:schemeClr val="accent1"/>
-          </a:lnRef>
-          <a:fillRef idx="0">
-            <a:schemeClr val="accent1"/>
-          </a:fillRef>
-          <a:effectRef idx="1">
-            <a:schemeClr val="accent1"/>
-          </a:effectRef>
-          <a:fontRef idx="minor">
-            <a:schemeClr val="tx1"/>
-          </a:fontRef>
-        </p:style>
-      </p:cxnSp>
-      <p:sp>
-        <p:nvSpPr>
-          <p:cNvPr id="13" name="Rounded Rectangle 12"/>
-          <p:cNvSpPr/>
-          <p:nvPr/>
-        </p:nvSpPr>
-        <p:spPr>
-          <a:xfrm>
-            <a:off x="594360" y="2898648"/>
-            <a:ext cx="5120640" cy="841248"/>
-          </a:xfrm>
-          <a:prstGeom prst="roundRect">
-            <a:avLst>
-              <a:gd name="adj" fmla="val 15000"/>
-            </a:avLst>
-          </a:prstGeom>
-          <a:solidFill>
-            <a:srgbClr val="EAF3FA"/>
-          </a:solidFill>
-          <a:ln>
-            <a:noFill/>
-          </a:ln>
-          <a:effectLst/>
-        </p:spPr>
-        <p:style>
-          <a:lnRef idx="1">
-            <a:schemeClr val="accent1"/>
-          </a:lnRef>
-          <a:fillRef idx="3">
-            <a:schemeClr val="accent1"/>
-          </a:fillRef>
-          <a:effectRef idx="2">
-            <a:schemeClr val="accent1"/>
-          </a:effectRef>
-          <a:fontRef idx="minor">
-            <a:schemeClr val="lt1"/>
-          </a:fontRef>
-        </p:style>
-        <p:txBody>
-          <a:bodyPr rtlCol="0" anchor="ctr" wrap="square" tIns="36576" bIns="36576">
-            <a:noAutofit/>
-          </a:bodyPr>
-          <a:lstStyle/>
-          <a:p>
-            <a:pPr algn="l"/>
-            <a:r>
-              <a:rPr sz="1600" b="0" i="0">
-                <a:solidFill>
-                  <a:srgbClr val="335B74"/>
-                </a:solidFill>
-                <a:latin typeface="Calibri"/>
-              </a:rPr>
-              <a:t>Constraint handling differs between algorithms</a:t>
-            </a:r>
-          </a:p>
-        </p:txBody>
-      </p:sp>
-      <p:sp>
-        <p:nvSpPr>
-          <p:cNvPr id="14" name="Rounded Rectangle 13"/>
-          <p:cNvSpPr/>
-          <p:nvPr/>
-        </p:nvSpPr>
-        <p:spPr>
-          <a:xfrm>
-            <a:off x="6492240" y="2898648"/>
-            <a:ext cx="5212080" cy="841248"/>
-          </a:xfrm>
-          <a:prstGeom prst="roundRect">
-            <a:avLst>
-              <a:gd name="adj" fmla="val 15000"/>
-            </a:avLst>
-          </a:prstGeom>
-          <a:solidFill>
-            <a:srgbClr val="FBEFE3"/>
-          </a:solidFill>
-          <a:ln>
-            <a:noFill/>
-          </a:ln>
-          <a:effectLst/>
-        </p:spPr>
-        <p:style>
-          <a:lnRef idx="1">
-            <a:schemeClr val="accent1"/>
-          </a:lnRef>
-          <a:fillRef idx="3">
-            <a:schemeClr val="accent1"/>
-          </a:fillRef>
-          <a:effectRef idx="2">
-            <a:schemeClr val="accent1"/>
-          </a:effectRef>
-          <a:fontRef idx="minor">
-            <a:schemeClr val="lt1"/>
-          </a:fontRef>
-        </p:style>
-        <p:txBody>
-          <a:bodyPr rtlCol="0" anchor="ctr" wrap="square" tIns="36576" bIns="36576">
-            <a:noAutofit/>
-          </a:bodyPr>
-          <a:lstStyle/>
-          <a:p>
-            <a:pPr algn="l"/>
-            <a:r>
-              <a:rPr sz="1600" b="0" i="0">
-                <a:solidFill>
-                  <a:srgbClr val="335B74"/>
-                </a:solidFill>
-                <a:latin typeface="Calibri"/>
-              </a:rPr>
-              <a:t>One shared repair operator for the swarm and the GA</a:t>
-            </a:r>
-          </a:p>
-        </p:txBody>
-      </p:sp>
-      <p:cxnSp>
-        <p:nvCxnSpPr>
-          <p:cNvPr id="15" name="Connector 14"/>
-          <p:cNvCxnSpPr/>
-          <p:nvPr/>
-        </p:nvCxnSpPr>
-        <p:spPr>
-          <a:xfrm>
-            <a:off x="5760720" y="3319272"/>
-            <a:ext cx="685800" cy="0"/>
-          </a:xfrm>
-          <a:prstGeom prst="line">
-            <a:avLst/>
-          </a:prstGeom>
-          <a:ln w="22225">
-            <a:solidFill>
-              <a:srgbClr val="335B74"/>
-            </a:solidFill>
-            <a:tailEnd type="triangle"/>
-          </a:ln>
-        </p:spPr>
-        <p:style>
-          <a:lnRef idx="2">
-            <a:schemeClr val="accent1"/>
-          </a:lnRef>
-          <a:fillRef idx="0">
-            <a:schemeClr val="accent1"/>
-          </a:fillRef>
-          <a:effectRef idx="1">
-            <a:schemeClr val="accent1"/>
-          </a:effectRef>
-          <a:fontRef idx="minor">
-            <a:schemeClr val="tx1"/>
-          </a:fontRef>
-        </p:style>
-      </p:cxnSp>
-      <p:sp>
-        <p:nvSpPr>
-          <p:cNvPr id="16" name="Rounded Rectangle 15"/>
-          <p:cNvSpPr/>
-          <p:nvPr/>
-        </p:nvSpPr>
-        <p:spPr>
-          <a:xfrm>
-            <a:off x="594360" y="3922776"/>
-            <a:ext cx="5120640" cy="841248"/>
-          </a:xfrm>
-          <a:prstGeom prst="roundRect">
-            <a:avLst>
-              <a:gd name="adj" fmla="val 15000"/>
-            </a:avLst>
-          </a:prstGeom>
-          <a:solidFill>
-            <a:srgbClr val="EAF3FA"/>
-          </a:solidFill>
-          <a:ln>
-            <a:noFill/>
-          </a:ln>
-          <a:effectLst/>
-        </p:spPr>
-        <p:style>
-          <a:lnRef idx="1">
-            <a:schemeClr val="accent1"/>
-          </a:lnRef>
-          <a:fillRef idx="3">
-            <a:schemeClr val="accent1"/>
-          </a:fillRef>
-          <a:effectRef idx="2">
-            <a:schemeClr val="accent1"/>
-          </a:effectRef>
-          <a:fontRef idx="minor">
-            <a:schemeClr val="lt1"/>
-          </a:fontRef>
-        </p:style>
-        <p:txBody>
-          <a:bodyPr rtlCol="0" anchor="ctr" wrap="square" tIns="36576" bIns="36576">
-            <a:noAutofit/>
-          </a:bodyPr>
-          <a:lstStyle/>
-          <a:p>
-            <a:pPr algn="l"/>
-            <a:r>
-              <a:rPr sz="1600" b="0" i="0">
-                <a:solidFill>
-                  <a:srgbClr val="335B74"/>
-                </a:solidFill>
-                <a:latin typeface="Calibri"/>
-              </a:rPr>
-              <a:t>Swarm studies use a single scalarised objective</a:t>
-            </a:r>
-          </a:p>
-        </p:txBody>
-      </p:sp>
-      <p:sp>
-        <p:nvSpPr>
-          <p:cNvPr id="17" name="Rounded Rectangle 16"/>
-          <p:cNvSpPr/>
-          <p:nvPr/>
-        </p:nvSpPr>
-        <p:spPr>
-          <a:xfrm>
-            <a:off x="6492240" y="3922776"/>
-            <a:ext cx="5212080" cy="841248"/>
-          </a:xfrm>
-          <a:prstGeom prst="roundRect">
-            <a:avLst>
-              <a:gd name="adj" fmla="val 15000"/>
-            </a:avLst>
-          </a:prstGeom>
-          <a:solidFill>
-            <a:srgbClr val="FBEFE3"/>
-          </a:solidFill>
-          <a:ln>
-            <a:noFill/>
-          </a:ln>
-          <a:effectLst/>
-        </p:spPr>
-        <p:style>
-          <a:lnRef idx="1">
-            <a:schemeClr val="accent1"/>
-          </a:lnRef>
-          <a:fillRef idx="3">
-            <a:schemeClr val="accent1"/>
-          </a:fillRef>
-          <a:effectRef idx="2">
-            <a:schemeClr val="accent1"/>
-          </a:effectRef>
-          <a:fontRef idx="minor">
-            <a:schemeClr val="lt1"/>
-          </a:fontRef>
-        </p:style>
-        <p:txBody>
-          <a:bodyPr rtlCol="0" anchor="ctr" wrap="square" tIns="36576" bIns="36576">
-            <a:noAutofit/>
-          </a:bodyPr>
-          <a:lstStyle/>
-          <a:p>
-            <a:pPr algn="l"/>
-            <a:r>
-              <a:rPr sz="1600" b="0" i="0">
-                <a:solidFill>
-                  <a:srgbClr val="335B74"/>
-                </a:solidFill>
-                <a:latin typeface="Calibri"/>
-              </a:rPr>
-              <a:t>Three-objective model: return, volatility, CVaR</a:t>
-            </a:r>
-          </a:p>
-        </p:txBody>
-      </p:sp>
-      <p:cxnSp>
-        <p:nvCxnSpPr>
-          <p:cNvPr id="18" name="Connector 17"/>
-          <p:cNvCxnSpPr/>
-          <p:nvPr/>
-        </p:nvCxnSpPr>
-        <p:spPr>
-          <a:xfrm>
-            <a:off x="5760720" y="4343400"/>
-            <a:ext cx="685800" cy="0"/>
-          </a:xfrm>
-          <a:prstGeom prst="line">
-            <a:avLst/>
-          </a:prstGeom>
-          <a:ln w="22225">
-            <a:solidFill>
-              <a:srgbClr val="335B74"/>
-            </a:solidFill>
-            <a:tailEnd type="triangle"/>
-          </a:ln>
-        </p:spPr>
-        <p:style>
-          <a:lnRef idx="2">
-            <a:schemeClr val="accent1"/>
-          </a:lnRef>
-          <a:fillRef idx="0">
-            <a:schemeClr val="accent1"/>
-          </a:fillRef>
-          <a:effectRef idx="1">
-            <a:schemeClr val="accent1"/>
-          </a:effectRef>
-          <a:fontRef idx="minor">
-            <a:schemeClr val="tx1"/>
-          </a:fontRef>
-        </p:style>
-      </p:cxnSp>
-      <p:sp>
-        <p:nvSpPr>
-          <p:cNvPr id="19" name="Rounded Rectangle 18"/>
-          <p:cNvSpPr/>
-          <p:nvPr/>
-        </p:nvSpPr>
-        <p:spPr>
-          <a:xfrm>
-            <a:off x="594360" y="4946904"/>
-            <a:ext cx="5120640" cy="841248"/>
-          </a:xfrm>
-          <a:prstGeom prst="roundRect">
-            <a:avLst>
-              <a:gd name="adj" fmla="val 15000"/>
-            </a:avLst>
-          </a:prstGeom>
-          <a:solidFill>
-            <a:srgbClr val="EAF3FA"/>
-          </a:solidFill>
-          <a:ln>
-            <a:noFill/>
-          </a:ln>
-          <a:effectLst/>
-        </p:spPr>
-        <p:style>
-          <a:lnRef idx="1">
-            <a:schemeClr val="accent1"/>
-          </a:lnRef>
-          <a:fillRef idx="3">
-            <a:schemeClr val="accent1"/>
-          </a:fillRef>
-          <a:effectRef idx="2">
-            <a:schemeClr val="accent1"/>
-          </a:effectRef>
-          <a:fontRef idx="minor">
-            <a:schemeClr val="lt1"/>
-          </a:fontRef>
-        </p:style>
-        <p:txBody>
-          <a:bodyPr rtlCol="0" anchor="ctr" wrap="square" tIns="36576" bIns="36576">
-            <a:noAutofit/>
-          </a:bodyPr>
-          <a:lstStyle/>
-          <a:p>
-            <a:pPr algn="l"/>
-            <a:r>
-              <a:rPr sz="1600" b="0" i="0">
-                <a:solidFill>
-                  <a:srgbClr val="335B74"/>
-                </a:solidFill>
-                <a:latin typeface="Calibri"/>
-              </a:rPr>
-              <a:t>Few tools let you watch and inspect the search</a:t>
-            </a:r>
-          </a:p>
-        </p:txBody>
-      </p:sp>
-      <p:sp>
-        <p:nvSpPr>
-          <p:cNvPr id="20" name="Rounded Rectangle 19"/>
-          <p:cNvSpPr/>
-          <p:nvPr/>
-        </p:nvSpPr>
-        <p:spPr>
-          <a:xfrm>
-            <a:off x="6492240" y="4946904"/>
-            <a:ext cx="5212080" cy="841248"/>
-          </a:xfrm>
-          <a:prstGeom prst="roundRect">
-            <a:avLst>
-              <a:gd name="adj" fmla="val 15000"/>
-            </a:avLst>
-          </a:prstGeom>
-          <a:solidFill>
-            <a:srgbClr val="FBEFE3"/>
-          </a:solidFill>
-          <a:ln>
-            <a:noFill/>
-          </a:ln>
-          <a:effectLst/>
-        </p:spPr>
-        <p:style>
-          <a:lnRef idx="1">
-            <a:schemeClr val="accent1"/>
-          </a:lnRef>
-          <a:fillRef idx="3">
-            <a:schemeClr val="accent1"/>
-          </a:fillRef>
-          <a:effectRef idx="2">
-            <a:schemeClr val="accent1"/>
-          </a:effectRef>
-          <a:fontRef idx="minor">
-            <a:schemeClr val="lt1"/>
-          </a:fontRef>
-        </p:style>
-        <p:txBody>
-          <a:bodyPr rtlCol="0" anchor="ctr" wrap="square" tIns="36576" bIns="36576">
-            <a:noAutofit/>
-          </a:bodyPr>
-          <a:lstStyle/>
-          <a:p>
-            <a:pPr algn="l"/>
-            <a:r>
-              <a:rPr sz="1600" b="0" i="0">
-                <a:solidFill>
-                  <a:srgbClr val="335B74"/>
-                </a:solidFill>
-                <a:latin typeface="Calibri"/>
-              </a:rPr>
-              <a:t>Browser workbench with live search and portfolio inspector</a:t>
-            </a:r>
-          </a:p>
-        </p:txBody>
-      </p:sp>
-      <p:cxnSp>
-        <p:nvCxnSpPr>
-          <p:cNvPr id="21" name="Connector 20"/>
-          <p:cNvCxnSpPr/>
-          <p:nvPr/>
-        </p:nvCxnSpPr>
-        <p:spPr>
-          <a:xfrm>
-            <a:off x="5760720" y="5367528"/>
-            <a:ext cx="685800" cy="0"/>
-          </a:xfrm>
-          <a:prstGeom prst="line">
-            <a:avLst/>
-          </a:prstGeom>
-          <a:ln w="22225">
-            <a:solidFill>
-              <a:srgbClr val="335B74"/>
-            </a:solidFill>
-            <a:tailEnd type="triangle"/>
-          </a:ln>
-        </p:spPr>
-        <p:style>
-          <a:lnRef idx="2">
-            <a:schemeClr val="accent1"/>
-          </a:lnRef>
-          <a:fillRef idx="0">
-            <a:schemeClr val="accent1"/>
-          </a:fillRef>
-          <a:effectRef idx="1">
-            <a:schemeClr val="accent1"/>
-          </a:effectRef>
-          <a:fontRef idx="minor">
-            <a:schemeClr val="tx1"/>
-          </a:fontRef>
-        </p:style>
-      </p:cxnSp>
-      <p:sp>
-        <p:nvSpPr>
-          <p:cNvPr id="22" name="TextBox 21"/>
-          <p:cNvSpPr txBox="1"/>
-          <p:nvPr/>
-        </p:nvSpPr>
-        <p:spPr>
-          <a:xfrm>
-            <a:off x="594360" y="5943600"/>
-            <a:ext cx="11064240" cy="365760"/>
-          </a:xfrm>
-          <a:prstGeom prst="rect">
-            <a:avLst/>
-          </a:prstGeom>
-          <a:noFill/>
-        </p:spPr>
-        <p:txBody>
-          <a:bodyPr wrap="square" lIns="45720" rIns="45720" tIns="27432" bIns="27432" anchor="t">
-            <a:noAutofit/>
-          </a:bodyPr>
-          <a:lstStyle/>
-          <a:p>
-            <a:pPr algn="l"/>
-            <a:r>
-              <a:rPr sz="1300" b="0" i="0">
-                <a:solidFill>
-                  <a:srgbClr val="8A97A8"/>
-                </a:solidFill>
-                <a:latin typeface="Calibri"/>
-              </a:rPr>
-              <a:t>Gaps refer to the papers surveyed here, not the whole field</a:t>
-            </a:r>
-          </a:p>
-        </p:txBody>
-      </p:sp>
-    </p:spTree>
-    <p:extLst>
-      <p:ext uri="{BB962C8B-B14F-4D97-AF65-F5344CB8AC3E}">
-        <p14:creationId xmlns:p14="http://schemas.microsoft.com/office/powerpoint/2010/main" val="4191075325"/>
-      </p:ext>
-    </p:extLst>
-  </p:cSld>
-  <p:clrMapOvr>
-    <a:masterClrMapping/>
-  </p:clrMapOvr>
-</p:sld>
-</file>
-
 <file path=ppt/slides/slide8.xml><?xml version="1.0" encoding="utf-8"?>
 <p:sld xmlns:a="http://schemas.openxmlformats.org/drawingml/2006/main" xmlns:r="http://schemas.openxmlformats.org/officeDocument/2006/relationships" xmlns:p="http://schemas.openxmlformats.org/presentationml/2006/main">
   <p:cSld>

</xml_diff>

<commit_message>
Presentation: restore the gaps-and-objectives slide and redesign the requirements slide
Co-Authored-By: Claude Sonnet 5.5 <noreply@anthropic.com>
Claude-Session: https://claude.ai/code/session_013CSadMbHd5eZzDnpHkiwuR
</commit_message>
<xml_diff>
--- a/presentation/SwarmFolio_Final_Presentation.pptx
+++ b/presentation/SwarmFolio_Final_Presentation.pptx
@@ -14,6 +14,7 @@
     <p:sldId id="265" r:id="rId5"/>
     <p:sldId id="274" r:id="rId20"/>
     <p:sldId id="266" r:id="rId6"/>
+    <p:sldId id="275" r:id="rId21"/>
     <p:sldId id="267" r:id="rId7"/>
     <p:sldId id="268" r:id="rId8"/>
     <p:sldId id="276" r:id="rId22"/>
@@ -3040,6 +3041,76 @@
 </p:notes>
 </file>
 
+<file path=ppt/notesSlides/notesSlide7.xml><?xml version="1.0" encoding="utf-8"?>
+<p:notes xmlns:a="http://schemas.openxmlformats.org/drawingml/2006/main" xmlns:p="http://schemas.openxmlformats.org/presentationml/2006/main" xmlns:r="http://schemas.openxmlformats.org/officeDocument/2006/relationships">
+  <p:cSld>
+    <p:spTree>
+      <p:nvGrpSpPr>
+        <p:cNvPr id="1" name=""/>
+        <p:cNvGrpSpPr/>
+        <p:nvPr/>
+      </p:nvGrpSpPr>
+      <p:grpSpPr>
+        <a:xfrm>
+          <a:off x="0" y="0"/>
+          <a:ext cx="0" cy="0"/>
+          <a:chOff x="0" y="0"/>
+          <a:chExt cx="0" cy="0"/>
+        </a:xfrm>
+      </p:grpSpPr>
+      <p:sp>
+        <p:nvSpPr>
+          <p:cNvPr id="2" name="Slide Image Placeholder 1"/>
+          <p:cNvSpPr>
+            <a:spLocks noGrp="1"/>
+          </p:cNvSpPr>
+          <p:nvPr>
+            <p:ph type="sldImg" idx="2"/>
+          </p:nvPr>
+        </p:nvSpPr>
+        <p:spPr/>
+      </p:sp>
+      <p:sp>
+        <p:nvSpPr>
+          <p:cNvPr id="3" name="Notes Placeholder 2"/>
+          <p:cNvSpPr>
+            <a:spLocks noGrp="1"/>
+          </p:cNvSpPr>
+          <p:nvPr>
+            <p:ph type="body" idx="3" sz="quarter"/>
+          </p:nvPr>
+        </p:nvSpPr>
+        <p:spPr/>
+        <p:txBody>
+          <a:bodyPr/>
+          <a:lstStyle/>
+          <a:p>
+            <a:r>
+              <a:t>Research gap identification and the mapping of our objectives to those gaps. The claim is limited to the surveyed papers.</a:t>
+            </a:r>
+          </a:p>
+        </p:txBody>
+      </p:sp>
+      <p:sp>
+        <p:nvSpPr>
+          <p:cNvPr id="4" name="Slide Number Placeholder 3"/>
+          <p:cNvSpPr>
+            <a:spLocks noGrp="1"/>
+          </p:cNvSpPr>
+          <p:nvPr>
+            <p:ph type="sldNum" idx="5" sz="quarter"/>
+          </p:nvPr>
+        </p:nvSpPr>
+        <p:spPr/>
+      </p:sp>
+    </p:spTree>
+  </p:cSld>
+  <p:clrMapOvr>
+    <a:masterClrMapping/>
+  </p:clrMapOvr>
+</p:notes>
+</file>
+
 <file path=ppt/notesSlides/notesSlide8.xml><?xml version="1.0" encoding="utf-8"?>
 <p:notes xmlns:a="http://schemas.openxmlformats.org/drawingml/2006/main" xmlns:p="http://schemas.openxmlformats.org/presentationml/2006/main" xmlns:r="http://schemas.openxmlformats.org/officeDocument/2006/relationships">
   <p:cSld>
@@ -3085,7 +3156,7 @@
           <a:lstStyle/>
           <a:p>
             <a:r>
-              <a:t>Requirements cover data input, constraints, both optimisers, live progress, inspection and error messages. Everything runs on free software; a default run takes about a second and a half.</a:t>
+              <a:t>Requirements in one view: six things the system must do, four quality targets, and the free software stack. A default run takes about a second and a half.</a:t>
             </a:r>
           </a:p>
         </p:txBody>
@@ -17158,7 +17229,7 @@
                 </a:solidFill>
                 <a:latin typeface="Calibri"/>
               </a:rPr>
-              <a:t>7</a:t>
+              <a:t>8</a:t>
             </a:r>
           </a:p>
         </p:txBody>
@@ -17294,7 +17365,7 @@
                 </a:solidFill>
                 <a:latin typeface="Calibri"/>
               </a:rPr>
-              <a:t>8</a:t>
+              <a:t>9</a:t>
             </a:r>
           </a:p>
         </p:txBody>
@@ -17430,7 +17501,7 @@
                 </a:solidFill>
                 <a:latin typeface="Calibri"/>
               </a:rPr>
-              <a:t>10</a:t>
+              <a:t>11</a:t>
             </a:r>
           </a:p>
         </p:txBody>
@@ -17566,7 +17637,7 @@
                 </a:solidFill>
                 <a:latin typeface="Calibri"/>
               </a:rPr>
-              <a:t>12</a:t>
+              <a:t>13</a:t>
             </a:r>
           </a:p>
         </p:txBody>
@@ -17702,7 +17773,7 @@
                 </a:solidFill>
                 <a:latin typeface="Calibri"/>
               </a:rPr>
-              <a:t>13</a:t>
+              <a:t>14</a:t>
             </a:r>
           </a:p>
         </p:txBody>
@@ -17838,7 +17909,7 @@
                 </a:solidFill>
                 <a:latin typeface="Calibri"/>
               </a:rPr>
-              <a:t>17</a:t>
+              <a:t>18</a:t>
             </a:r>
           </a:p>
         </p:txBody>
@@ -17974,7 +18045,7 @@
                 </a:solidFill>
                 <a:latin typeface="Calibri"/>
               </a:rPr>
-              <a:t>18</a:t>
+              <a:t>19</a:t>
             </a:r>
           </a:p>
         </p:txBody>
@@ -22324,6 +22395,900 @@
 </p:sld>
 </file>
 
+<file path=ppt/slides/slide7.xml><?xml version="1.0" encoding="utf-8"?>
+<p:sld xmlns:a="http://schemas.openxmlformats.org/drawingml/2006/main" xmlns:r="http://schemas.openxmlformats.org/officeDocument/2006/relationships" xmlns:p="http://schemas.openxmlformats.org/presentationml/2006/main">
+  <p:cSld>
+    <p:spTree>
+      <p:nvGrpSpPr>
+        <p:cNvPr id="1" name=""/>
+        <p:cNvGrpSpPr/>
+        <p:nvPr/>
+      </p:nvGrpSpPr>
+      <p:grpSpPr>
+        <a:xfrm>
+          <a:off x="0" y="0"/>
+          <a:ext cx="0" cy="0"/>
+          <a:chOff x="0" y="0"/>
+          <a:chExt cx="0" cy="0"/>
+        </a:xfrm>
+      </p:grpSpPr>
+      <p:sp>
+        <p:nvSpPr>
+          <p:cNvPr id="2" name="Title 1">
+            <a:extLst>
+              <a:ext uri="{FF2B5EF4-FFF2-40B4-BE49-F238E27FC236}">
+                <a16:creationId xmlns:a16="http://schemas.microsoft.com/office/drawing/2014/main" id="{BD1A189D-22D1-4D1A-9E04-C6134EC51F8B}"/>
+              </a:ext>
+            </a:extLst>
+          </p:cNvPr>
+          <p:cNvSpPr>
+            <a:spLocks noGrp="1"/>
+          </p:cNvSpPr>
+          <p:nvPr>
+            <p:ph type="ctrTitle"/>
+          </p:nvPr>
+        </p:nvSpPr>
+        <p:spPr>
+          <a:xfrm>
+            <a:off x="1684868" y="203198"/>
+            <a:ext cx="9694332" cy="880535"/>
+          </a:xfrm>
+        </p:spPr>
+        <p:txBody>
+          <a:bodyPr>
+            <a:noAutofit/>
+          </a:bodyPr>
+          <a:lstStyle/>
+          <a:p>
+            <a:r>
+              <a:rPr sz="3600"/>
+              <a:t>Literature Survey: gaps and our objectives</a:t>
+            </a:r>
+          </a:p>
+        </p:txBody>
+      </p:sp>
+      <p:pic>
+        <p:nvPicPr>
+          <p:cNvPr id="5" name="Graphic 4">
+            <a:extLst>
+              <a:ext uri="{FF2B5EF4-FFF2-40B4-BE49-F238E27FC236}">
+                <a16:creationId xmlns:a16="http://schemas.microsoft.com/office/drawing/2014/main" id="{E7125167-8301-4D88-B79A-A8DA3C19E0D6}"/>
+              </a:ext>
+            </a:extLst>
+          </p:cNvPr>
+          <p:cNvPicPr>
+            <a:picLocks noChangeAspect="1"/>
+          </p:cNvPicPr>
+          <p:nvPr/>
+        </p:nvPicPr>
+        <p:blipFill>
+          <a:blip r:embed="rId2">
+            <a:extLst>
+              <a:ext uri="{96DAC541-7B7A-43D3-8B79-37D633B846F1}">
+                <asvg:svgBlip xmlns:asvg="http://schemas.microsoft.com/office/drawing/2016/SVG/main" r:embed="rId3"/>
+              </a:ext>
+            </a:extLst>
+          </a:blip>
+          <a:stretch>
+            <a:fillRect/>
+          </a:stretch>
+        </p:blipFill>
+        <p:spPr>
+          <a:xfrm>
+            <a:off x="127001" y="86782"/>
+            <a:ext cx="1159932" cy="1159932"/>
+          </a:xfrm>
+          <a:prstGeom prst="rect">
+            <a:avLst/>
+          </a:prstGeom>
+        </p:spPr>
+      </p:pic>
+      <p:sp>
+        <p:nvSpPr>
+          <p:cNvPr id="4" name="Date Placeholder 3">
+            <a:extLst>
+              <a:ext uri="{FF2B5EF4-FFF2-40B4-BE49-F238E27FC236}">
+                <a16:creationId xmlns:a16="http://schemas.microsoft.com/office/drawing/2014/main" id="{35032362-C5A5-4DBF-AD79-DE6FB7439999}"/>
+              </a:ext>
+            </a:extLst>
+          </p:cNvPr>
+          <p:cNvSpPr>
+            <a:spLocks noGrp="1"/>
+          </p:cNvSpPr>
+          <p:nvPr>
+            <p:ph type="dt" sz="half" idx="10"/>
+          </p:nvPr>
+        </p:nvSpPr>
+        <p:spPr/>
+        <p:txBody>
+          <a:bodyPr/>
+          <a:lstStyle/>
+          <a:p>
+            <a:fld id="{64C96E34-94C0-49E4-A53B-4A44141FD3C8}" type="datetime3">
+              <a:rPr lang="en-US" smtClean="0"/>
+              <a:t>14 October 2026</a:t>
+            </a:fld>
+            <a:endParaRPr lang="en-US" dirty="0"/>
+          </a:p>
+        </p:txBody>
+      </p:sp>
+      <p:sp>
+        <p:nvSpPr>
+          <p:cNvPr id="6" name="Slide Number Placeholder 5">
+            <a:extLst>
+              <a:ext uri="{FF2B5EF4-FFF2-40B4-BE49-F238E27FC236}">
+                <a16:creationId xmlns:a16="http://schemas.microsoft.com/office/drawing/2014/main" id="{115AAB64-5B51-4B5A-B69E-D96362CE6E74}"/>
+              </a:ext>
+            </a:extLst>
+          </p:cNvPr>
+          <p:cNvSpPr>
+            <a:spLocks noGrp="1"/>
+          </p:cNvSpPr>
+          <p:nvPr>
+            <p:ph type="sldNum" sz="quarter" idx="12"/>
+          </p:nvPr>
+        </p:nvSpPr>
+        <p:spPr/>
+        <p:txBody>
+          <a:bodyPr/>
+          <a:lstStyle/>
+          <a:p>
+            <a:fld id="{D57F1E4F-1CFF-5643-939E-217C01CDF565}" type="slidenum">
+              <a:rPr lang="en-US" smtClean="0"/>
+              <a:pPr/>
+              <a:t>5</a:t>
+            </a:fld>
+            <a:endParaRPr lang="en-US" dirty="0"/>
+          </a:p>
+        </p:txBody>
+      </p:sp>
+      <p:sp>
+        <p:nvSpPr>
+          <p:cNvPr id="7" name="Footer Placeholder 6">
+            <a:extLst>
+              <a:ext uri="{FF2B5EF4-FFF2-40B4-BE49-F238E27FC236}">
+                <a16:creationId xmlns:a16="http://schemas.microsoft.com/office/drawing/2014/main" id="{8683C6DF-27D9-468B-A1AB-FE568488FE57}"/>
+              </a:ext>
+            </a:extLst>
+          </p:cNvPr>
+          <p:cNvSpPr>
+            <a:spLocks noGrp="1"/>
+          </p:cNvSpPr>
+          <p:nvPr>
+            <p:ph type="ftr" sz="quarter" idx="11"/>
+          </p:nvPr>
+        </p:nvSpPr>
+        <p:spPr/>
+        <p:txBody>
+          <a:bodyPr/>
+          <a:lstStyle/>
+          <a:p>
+            <a:r>
+              <a:rPr lang="en-US"/>
+              <a:t>Dept of AI &amp; DS</a:t>
+            </a:r>
+            <a:endParaRPr lang="en-US" dirty="0"/>
+          </a:p>
+        </p:txBody>
+      </p:sp>
+      <p:sp>
+        <p:nvSpPr>
+          <p:cNvPr id="8" name="TextBox 7"/>
+          <p:cNvSpPr txBox="1"/>
+          <p:nvPr/>
+        </p:nvSpPr>
+        <p:spPr>
+          <a:xfrm>
+            <a:off x="594360" y="1371600"/>
+            <a:ext cx="4937760" cy="365760"/>
+          </a:xfrm>
+          <a:prstGeom prst="rect">
+            <a:avLst/>
+          </a:prstGeom>
+          <a:noFill/>
+        </p:spPr>
+        <p:txBody>
+          <a:bodyPr wrap="square" lIns="45720" rIns="45720" tIns="27432" bIns="27432" anchor="t">
+            <a:noAutofit/>
+          </a:bodyPr>
+          <a:lstStyle/>
+          <a:p>
+            <a:pPr algn="l"/>
+            <a:r>
+              <a:rPr sz="1800" b="1" i="0">
+                <a:solidFill>
+                  <a:srgbClr val="2683C6"/>
+                </a:solidFill>
+                <a:latin typeface="Calibri"/>
+              </a:rPr>
+              <a:t>Research gap identified</a:t>
+            </a:r>
+          </a:p>
+        </p:txBody>
+      </p:sp>
+      <p:sp>
+        <p:nvSpPr>
+          <p:cNvPr id="9" name="TextBox 8"/>
+          <p:cNvSpPr txBox="1"/>
+          <p:nvPr/>
+        </p:nvSpPr>
+        <p:spPr>
+          <a:xfrm>
+            <a:off x="6720840" y="1371600"/>
+            <a:ext cx="4937760" cy="365760"/>
+          </a:xfrm>
+          <a:prstGeom prst="rect">
+            <a:avLst/>
+          </a:prstGeom>
+          <a:noFill/>
+        </p:spPr>
+        <p:txBody>
+          <a:bodyPr wrap="square" lIns="45720" rIns="45720" tIns="27432" bIns="27432" anchor="t">
+            <a:noAutofit/>
+          </a:bodyPr>
+          <a:lstStyle/>
+          <a:p>
+            <a:pPr algn="l"/>
+            <a:r>
+              <a:rPr sz="1800" b="1" i="0">
+                <a:solidFill>
+                  <a:srgbClr val="D9731A"/>
+                </a:solidFill>
+                <a:latin typeface="Calibri"/>
+              </a:rPr>
+              <a:t>Our objective that addresses it</a:t>
+            </a:r>
+          </a:p>
+        </p:txBody>
+      </p:sp>
+      <p:sp>
+        <p:nvSpPr>
+          <p:cNvPr id="10" name="Rounded Rectangle 9"/>
+          <p:cNvSpPr/>
+          <p:nvPr/>
+        </p:nvSpPr>
+        <p:spPr>
+          <a:xfrm>
+            <a:off x="594360" y="1874519"/>
+            <a:ext cx="5120640" cy="841248"/>
+          </a:xfrm>
+          <a:prstGeom prst="roundRect">
+            <a:avLst>
+              <a:gd name="adj" fmla="val 15000"/>
+            </a:avLst>
+          </a:prstGeom>
+          <a:solidFill>
+            <a:srgbClr val="EAF3FA"/>
+          </a:solidFill>
+          <a:ln>
+            <a:noFill/>
+          </a:ln>
+          <a:effectLst/>
+        </p:spPr>
+        <p:style>
+          <a:lnRef idx="1">
+            <a:schemeClr val="accent1"/>
+          </a:lnRef>
+          <a:fillRef idx="3">
+            <a:schemeClr val="accent1"/>
+          </a:fillRef>
+          <a:effectRef idx="2">
+            <a:schemeClr val="accent1"/>
+          </a:effectRef>
+          <a:fontRef idx="minor">
+            <a:schemeClr val="lt1"/>
+          </a:fontRef>
+        </p:style>
+        <p:txBody>
+          <a:bodyPr rtlCol="0" anchor="ctr" wrap="square" tIns="36576" bIns="36576">
+            <a:noAutofit/>
+          </a:bodyPr>
+          <a:lstStyle/>
+          <a:p>
+            <a:pPr algn="l"/>
+            <a:r>
+              <a:rPr sz="1600" b="0" i="0">
+                <a:solidFill>
+                  <a:srgbClr val="335B74"/>
+                </a:solidFill>
+                <a:latin typeface="Calibri"/>
+              </a:rPr>
+              <a:t>Held-out testing across many markets is rare</a:t>
+            </a:r>
+          </a:p>
+        </p:txBody>
+      </p:sp>
+      <p:sp>
+        <p:nvSpPr>
+          <p:cNvPr id="11" name="Rounded Rectangle 10"/>
+          <p:cNvSpPr/>
+          <p:nvPr/>
+        </p:nvSpPr>
+        <p:spPr>
+          <a:xfrm>
+            <a:off x="6492240" y="1874519"/>
+            <a:ext cx="5212080" cy="841248"/>
+          </a:xfrm>
+          <a:prstGeom prst="roundRect">
+            <a:avLst>
+              <a:gd name="adj" fmla="val 15000"/>
+            </a:avLst>
+          </a:prstGeom>
+          <a:solidFill>
+            <a:srgbClr val="FBEFE3"/>
+          </a:solidFill>
+          <a:ln>
+            <a:noFill/>
+          </a:ln>
+          <a:effectLst/>
+        </p:spPr>
+        <p:style>
+          <a:lnRef idx="1">
+            <a:schemeClr val="accent1"/>
+          </a:lnRef>
+          <a:fillRef idx="3">
+            <a:schemeClr val="accent1"/>
+          </a:fillRef>
+          <a:effectRef idx="2">
+            <a:schemeClr val="accent1"/>
+          </a:effectRef>
+          <a:fontRef idx="minor">
+            <a:schemeClr val="lt1"/>
+          </a:fontRef>
+        </p:style>
+        <p:txBody>
+          <a:bodyPr rtlCol="0" anchor="ctr" wrap="square" tIns="36576" bIns="36576">
+            <a:noAutofit/>
+          </a:bodyPr>
+          <a:lstStyle/>
+          <a:p>
+            <a:pPr algn="l"/>
+            <a:r>
+              <a:rPr sz="1600" b="0" i="0">
+                <a:solidFill>
+                  <a:srgbClr val="335B74"/>
+                </a:solidFill>
+                <a:latin typeface="Calibri"/>
+              </a:rPr>
+              <a:t>Test portfolios on 30 simulated markets with a paired test</a:t>
+            </a:r>
+          </a:p>
+        </p:txBody>
+      </p:sp>
+      <p:cxnSp>
+        <p:nvCxnSpPr>
+          <p:cNvPr id="12" name="Connector 11"/>
+          <p:cNvCxnSpPr/>
+          <p:nvPr/>
+        </p:nvCxnSpPr>
+        <p:spPr>
+          <a:xfrm>
+            <a:off x="5760720" y="2295144"/>
+            <a:ext cx="685800" cy="0"/>
+          </a:xfrm>
+          <a:prstGeom prst="line">
+            <a:avLst/>
+          </a:prstGeom>
+          <a:ln w="22225">
+            <a:solidFill>
+              <a:srgbClr val="335B74"/>
+            </a:solidFill>
+            <a:tailEnd type="triangle"/>
+          </a:ln>
+        </p:spPr>
+        <p:style>
+          <a:lnRef idx="2">
+            <a:schemeClr val="accent1"/>
+          </a:lnRef>
+          <a:fillRef idx="0">
+            <a:schemeClr val="accent1"/>
+          </a:fillRef>
+          <a:effectRef idx="1">
+            <a:schemeClr val="accent1"/>
+          </a:effectRef>
+          <a:fontRef idx="minor">
+            <a:schemeClr val="tx1"/>
+          </a:fontRef>
+        </p:style>
+      </p:cxnSp>
+      <p:sp>
+        <p:nvSpPr>
+          <p:cNvPr id="13" name="Rounded Rectangle 12"/>
+          <p:cNvSpPr/>
+          <p:nvPr/>
+        </p:nvSpPr>
+        <p:spPr>
+          <a:xfrm>
+            <a:off x="594360" y="2898648"/>
+            <a:ext cx="5120640" cy="841248"/>
+          </a:xfrm>
+          <a:prstGeom prst="roundRect">
+            <a:avLst>
+              <a:gd name="adj" fmla="val 15000"/>
+            </a:avLst>
+          </a:prstGeom>
+          <a:solidFill>
+            <a:srgbClr val="EAF3FA"/>
+          </a:solidFill>
+          <a:ln>
+            <a:noFill/>
+          </a:ln>
+          <a:effectLst/>
+        </p:spPr>
+        <p:style>
+          <a:lnRef idx="1">
+            <a:schemeClr val="accent1"/>
+          </a:lnRef>
+          <a:fillRef idx="3">
+            <a:schemeClr val="accent1"/>
+          </a:fillRef>
+          <a:effectRef idx="2">
+            <a:schemeClr val="accent1"/>
+          </a:effectRef>
+          <a:fontRef idx="minor">
+            <a:schemeClr val="lt1"/>
+          </a:fontRef>
+        </p:style>
+        <p:txBody>
+          <a:bodyPr rtlCol="0" anchor="ctr" wrap="square" tIns="36576" bIns="36576">
+            <a:noAutofit/>
+          </a:bodyPr>
+          <a:lstStyle/>
+          <a:p>
+            <a:pPr algn="l"/>
+            <a:r>
+              <a:rPr sz="1600" b="0" i="0">
+                <a:solidFill>
+                  <a:srgbClr val="335B74"/>
+                </a:solidFill>
+                <a:latin typeface="Calibri"/>
+              </a:rPr>
+              <a:t>Constraint handling differs between algorithms</a:t>
+            </a:r>
+          </a:p>
+        </p:txBody>
+      </p:sp>
+      <p:sp>
+        <p:nvSpPr>
+          <p:cNvPr id="14" name="Rounded Rectangle 13"/>
+          <p:cNvSpPr/>
+          <p:nvPr/>
+        </p:nvSpPr>
+        <p:spPr>
+          <a:xfrm>
+            <a:off x="6492240" y="2898648"/>
+            <a:ext cx="5212080" cy="841248"/>
+          </a:xfrm>
+          <a:prstGeom prst="roundRect">
+            <a:avLst>
+              <a:gd name="adj" fmla="val 15000"/>
+            </a:avLst>
+          </a:prstGeom>
+          <a:solidFill>
+            <a:srgbClr val="FBEFE3"/>
+          </a:solidFill>
+          <a:ln>
+            <a:noFill/>
+          </a:ln>
+          <a:effectLst/>
+        </p:spPr>
+        <p:style>
+          <a:lnRef idx="1">
+            <a:schemeClr val="accent1"/>
+          </a:lnRef>
+          <a:fillRef idx="3">
+            <a:schemeClr val="accent1"/>
+          </a:fillRef>
+          <a:effectRef idx="2">
+            <a:schemeClr val="accent1"/>
+          </a:effectRef>
+          <a:fontRef idx="minor">
+            <a:schemeClr val="lt1"/>
+          </a:fontRef>
+        </p:style>
+        <p:txBody>
+          <a:bodyPr rtlCol="0" anchor="ctr" wrap="square" tIns="36576" bIns="36576">
+            <a:noAutofit/>
+          </a:bodyPr>
+          <a:lstStyle/>
+          <a:p>
+            <a:pPr algn="l"/>
+            <a:r>
+              <a:rPr sz="1600" b="0" i="0">
+                <a:solidFill>
+                  <a:srgbClr val="335B74"/>
+                </a:solidFill>
+                <a:latin typeface="Calibri"/>
+              </a:rPr>
+              <a:t>One shared repair operator for the swarm and the GA</a:t>
+            </a:r>
+          </a:p>
+        </p:txBody>
+      </p:sp>
+      <p:cxnSp>
+        <p:nvCxnSpPr>
+          <p:cNvPr id="15" name="Connector 14"/>
+          <p:cNvCxnSpPr/>
+          <p:nvPr/>
+        </p:nvCxnSpPr>
+        <p:spPr>
+          <a:xfrm>
+            <a:off x="5760720" y="3319272"/>
+            <a:ext cx="685800" cy="0"/>
+          </a:xfrm>
+          <a:prstGeom prst="line">
+            <a:avLst/>
+          </a:prstGeom>
+          <a:ln w="22225">
+            <a:solidFill>
+              <a:srgbClr val="335B74"/>
+            </a:solidFill>
+            <a:tailEnd type="triangle"/>
+          </a:ln>
+        </p:spPr>
+        <p:style>
+          <a:lnRef idx="2">
+            <a:schemeClr val="accent1"/>
+          </a:lnRef>
+          <a:fillRef idx="0">
+            <a:schemeClr val="accent1"/>
+          </a:fillRef>
+          <a:effectRef idx="1">
+            <a:schemeClr val="accent1"/>
+          </a:effectRef>
+          <a:fontRef idx="minor">
+            <a:schemeClr val="tx1"/>
+          </a:fontRef>
+        </p:style>
+      </p:cxnSp>
+      <p:sp>
+        <p:nvSpPr>
+          <p:cNvPr id="16" name="Rounded Rectangle 15"/>
+          <p:cNvSpPr/>
+          <p:nvPr/>
+        </p:nvSpPr>
+        <p:spPr>
+          <a:xfrm>
+            <a:off x="594360" y="3922776"/>
+            <a:ext cx="5120640" cy="841248"/>
+          </a:xfrm>
+          <a:prstGeom prst="roundRect">
+            <a:avLst>
+              <a:gd name="adj" fmla="val 15000"/>
+            </a:avLst>
+          </a:prstGeom>
+          <a:solidFill>
+            <a:srgbClr val="EAF3FA"/>
+          </a:solidFill>
+          <a:ln>
+            <a:noFill/>
+          </a:ln>
+          <a:effectLst/>
+        </p:spPr>
+        <p:style>
+          <a:lnRef idx="1">
+            <a:schemeClr val="accent1"/>
+          </a:lnRef>
+          <a:fillRef idx="3">
+            <a:schemeClr val="accent1"/>
+          </a:fillRef>
+          <a:effectRef idx="2">
+            <a:schemeClr val="accent1"/>
+          </a:effectRef>
+          <a:fontRef idx="minor">
+            <a:schemeClr val="lt1"/>
+          </a:fontRef>
+        </p:style>
+        <p:txBody>
+          <a:bodyPr rtlCol="0" anchor="ctr" wrap="square" tIns="36576" bIns="36576">
+            <a:noAutofit/>
+          </a:bodyPr>
+          <a:lstStyle/>
+          <a:p>
+            <a:pPr algn="l"/>
+            <a:r>
+              <a:rPr sz="1600" b="0" i="0">
+                <a:solidFill>
+                  <a:srgbClr val="335B74"/>
+                </a:solidFill>
+                <a:latin typeface="Calibri"/>
+              </a:rPr>
+              <a:t>Swarm studies use a single scalarised objective</a:t>
+            </a:r>
+          </a:p>
+        </p:txBody>
+      </p:sp>
+      <p:sp>
+        <p:nvSpPr>
+          <p:cNvPr id="17" name="Rounded Rectangle 16"/>
+          <p:cNvSpPr/>
+          <p:nvPr/>
+        </p:nvSpPr>
+        <p:spPr>
+          <a:xfrm>
+            <a:off x="6492240" y="3922776"/>
+            <a:ext cx="5212080" cy="841248"/>
+          </a:xfrm>
+          <a:prstGeom prst="roundRect">
+            <a:avLst>
+              <a:gd name="adj" fmla="val 15000"/>
+            </a:avLst>
+          </a:prstGeom>
+          <a:solidFill>
+            <a:srgbClr val="FBEFE3"/>
+          </a:solidFill>
+          <a:ln>
+            <a:noFill/>
+          </a:ln>
+          <a:effectLst/>
+        </p:spPr>
+        <p:style>
+          <a:lnRef idx="1">
+            <a:schemeClr val="accent1"/>
+          </a:lnRef>
+          <a:fillRef idx="3">
+            <a:schemeClr val="accent1"/>
+          </a:fillRef>
+          <a:effectRef idx="2">
+            <a:schemeClr val="accent1"/>
+          </a:effectRef>
+          <a:fontRef idx="minor">
+            <a:schemeClr val="lt1"/>
+          </a:fontRef>
+        </p:style>
+        <p:txBody>
+          <a:bodyPr rtlCol="0" anchor="ctr" wrap="square" tIns="36576" bIns="36576">
+            <a:noAutofit/>
+          </a:bodyPr>
+          <a:lstStyle/>
+          <a:p>
+            <a:pPr algn="l"/>
+            <a:r>
+              <a:rPr sz="1600" b="0" i="0">
+                <a:solidFill>
+                  <a:srgbClr val="335B74"/>
+                </a:solidFill>
+                <a:latin typeface="Calibri"/>
+              </a:rPr>
+              <a:t>Three-objective model: return, volatility, CVaR</a:t>
+            </a:r>
+          </a:p>
+        </p:txBody>
+      </p:sp>
+      <p:cxnSp>
+        <p:nvCxnSpPr>
+          <p:cNvPr id="18" name="Connector 17"/>
+          <p:cNvCxnSpPr/>
+          <p:nvPr/>
+        </p:nvCxnSpPr>
+        <p:spPr>
+          <a:xfrm>
+            <a:off x="5760720" y="4343400"/>
+            <a:ext cx="685800" cy="0"/>
+          </a:xfrm>
+          <a:prstGeom prst="line">
+            <a:avLst/>
+          </a:prstGeom>
+          <a:ln w="22225">
+            <a:solidFill>
+              <a:srgbClr val="335B74"/>
+            </a:solidFill>
+            <a:tailEnd type="triangle"/>
+          </a:ln>
+        </p:spPr>
+        <p:style>
+          <a:lnRef idx="2">
+            <a:schemeClr val="accent1"/>
+          </a:lnRef>
+          <a:fillRef idx="0">
+            <a:schemeClr val="accent1"/>
+          </a:fillRef>
+          <a:effectRef idx="1">
+            <a:schemeClr val="accent1"/>
+          </a:effectRef>
+          <a:fontRef idx="minor">
+            <a:schemeClr val="tx1"/>
+          </a:fontRef>
+        </p:style>
+      </p:cxnSp>
+      <p:sp>
+        <p:nvSpPr>
+          <p:cNvPr id="19" name="Rounded Rectangle 18"/>
+          <p:cNvSpPr/>
+          <p:nvPr/>
+        </p:nvSpPr>
+        <p:spPr>
+          <a:xfrm>
+            <a:off x="594360" y="4946904"/>
+            <a:ext cx="5120640" cy="841248"/>
+          </a:xfrm>
+          <a:prstGeom prst="roundRect">
+            <a:avLst>
+              <a:gd name="adj" fmla="val 15000"/>
+            </a:avLst>
+          </a:prstGeom>
+          <a:solidFill>
+            <a:srgbClr val="EAF3FA"/>
+          </a:solidFill>
+          <a:ln>
+            <a:noFill/>
+          </a:ln>
+          <a:effectLst/>
+        </p:spPr>
+        <p:style>
+          <a:lnRef idx="1">
+            <a:schemeClr val="accent1"/>
+          </a:lnRef>
+          <a:fillRef idx="3">
+            <a:schemeClr val="accent1"/>
+          </a:fillRef>
+          <a:effectRef idx="2">
+            <a:schemeClr val="accent1"/>
+          </a:effectRef>
+          <a:fontRef idx="minor">
+            <a:schemeClr val="lt1"/>
+          </a:fontRef>
+        </p:style>
+        <p:txBody>
+          <a:bodyPr rtlCol="0" anchor="ctr" wrap="square" tIns="36576" bIns="36576">
+            <a:noAutofit/>
+          </a:bodyPr>
+          <a:lstStyle/>
+          <a:p>
+            <a:pPr algn="l"/>
+            <a:r>
+              <a:rPr sz="1600" b="0" i="0">
+                <a:solidFill>
+                  <a:srgbClr val="335B74"/>
+                </a:solidFill>
+                <a:latin typeface="Calibri"/>
+              </a:rPr>
+              <a:t>Few tools let you watch and inspect the search</a:t>
+            </a:r>
+          </a:p>
+        </p:txBody>
+      </p:sp>
+      <p:sp>
+        <p:nvSpPr>
+          <p:cNvPr id="20" name="Rounded Rectangle 19"/>
+          <p:cNvSpPr/>
+          <p:nvPr/>
+        </p:nvSpPr>
+        <p:spPr>
+          <a:xfrm>
+            <a:off x="6492240" y="4946904"/>
+            <a:ext cx="5212080" cy="841248"/>
+          </a:xfrm>
+          <a:prstGeom prst="roundRect">
+            <a:avLst>
+              <a:gd name="adj" fmla="val 15000"/>
+            </a:avLst>
+          </a:prstGeom>
+          <a:solidFill>
+            <a:srgbClr val="FBEFE3"/>
+          </a:solidFill>
+          <a:ln>
+            <a:noFill/>
+          </a:ln>
+          <a:effectLst/>
+        </p:spPr>
+        <p:style>
+          <a:lnRef idx="1">
+            <a:schemeClr val="accent1"/>
+          </a:lnRef>
+          <a:fillRef idx="3">
+            <a:schemeClr val="accent1"/>
+          </a:fillRef>
+          <a:effectRef idx="2">
+            <a:schemeClr val="accent1"/>
+          </a:effectRef>
+          <a:fontRef idx="minor">
+            <a:schemeClr val="lt1"/>
+          </a:fontRef>
+        </p:style>
+        <p:txBody>
+          <a:bodyPr rtlCol="0" anchor="ctr" wrap="square" tIns="36576" bIns="36576">
+            <a:noAutofit/>
+          </a:bodyPr>
+          <a:lstStyle/>
+          <a:p>
+            <a:pPr algn="l"/>
+            <a:r>
+              <a:rPr sz="1600" b="0" i="0">
+                <a:solidFill>
+                  <a:srgbClr val="335B74"/>
+                </a:solidFill>
+                <a:latin typeface="Calibri"/>
+              </a:rPr>
+              <a:t>Browser workbench with live search and portfolio inspector</a:t>
+            </a:r>
+          </a:p>
+        </p:txBody>
+      </p:sp>
+      <p:cxnSp>
+        <p:nvCxnSpPr>
+          <p:cNvPr id="21" name="Connector 20"/>
+          <p:cNvCxnSpPr/>
+          <p:nvPr/>
+        </p:nvCxnSpPr>
+        <p:spPr>
+          <a:xfrm>
+            <a:off x="5760720" y="5367528"/>
+            <a:ext cx="685800" cy="0"/>
+          </a:xfrm>
+          <a:prstGeom prst="line">
+            <a:avLst/>
+          </a:prstGeom>
+          <a:ln w="22225">
+            <a:solidFill>
+              <a:srgbClr val="335B74"/>
+            </a:solidFill>
+            <a:tailEnd type="triangle"/>
+          </a:ln>
+        </p:spPr>
+        <p:style>
+          <a:lnRef idx="2">
+            <a:schemeClr val="accent1"/>
+          </a:lnRef>
+          <a:fillRef idx="0">
+            <a:schemeClr val="accent1"/>
+          </a:fillRef>
+          <a:effectRef idx="1">
+            <a:schemeClr val="accent1"/>
+          </a:effectRef>
+          <a:fontRef idx="minor">
+            <a:schemeClr val="tx1"/>
+          </a:fontRef>
+        </p:style>
+      </p:cxnSp>
+      <p:sp>
+        <p:nvSpPr>
+          <p:cNvPr id="22" name="TextBox 21"/>
+          <p:cNvSpPr txBox="1"/>
+          <p:nvPr/>
+        </p:nvSpPr>
+        <p:spPr>
+          <a:xfrm>
+            <a:off x="594360" y="5943600"/>
+            <a:ext cx="11064240" cy="365760"/>
+          </a:xfrm>
+          <a:prstGeom prst="rect">
+            <a:avLst/>
+          </a:prstGeom>
+          <a:noFill/>
+        </p:spPr>
+        <p:txBody>
+          <a:bodyPr wrap="square" lIns="45720" rIns="45720" tIns="27432" bIns="27432" anchor="t">
+            <a:noAutofit/>
+          </a:bodyPr>
+          <a:lstStyle/>
+          <a:p>
+            <a:pPr algn="l"/>
+            <a:r>
+              <a:rPr sz="1300" b="0" i="0">
+                <a:solidFill>
+                  <a:srgbClr val="8A97A8"/>
+                </a:solidFill>
+                <a:latin typeface="Calibri"/>
+              </a:rPr>
+              <a:t>Gaps refer to the papers surveyed here, not the whole field</a:t>
+            </a:r>
+          </a:p>
+        </p:txBody>
+      </p:sp>
+    </p:spTree>
+    <p:extLst>
+      <p:ext uri="{BB962C8B-B14F-4D97-AF65-F5344CB8AC3E}">
+        <p14:creationId xmlns:p14="http://schemas.microsoft.com/office/powerpoint/2010/main" val="4191075325"/>
+      </p:ext>
+    </p:extLst>
+  </p:cSld>
+  <p:clrMapOvr>
+    <a:masterClrMapping/>
+  </p:clrMapOvr>
+</p:sld>
+</file>
+
 <file path=ppt/slides/slide8.xml><?xml version="1.0" encoding="utf-8"?>
 <p:sld xmlns:a="http://schemas.openxmlformats.org/drawingml/2006/main" xmlns:r="http://schemas.openxmlformats.org/officeDocument/2006/relationships" xmlns:p="http://schemas.openxmlformats.org/presentationml/2006/main">
   <p:cSld>
@@ -22502,22 +23467,57 @@
       </p:sp>
       <p:sp>
         <p:nvSpPr>
-          <p:cNvPr id="8" name="Stat 1"/>
+          <p:cNvPr id="8" name="TextBox 7"/>
+          <p:cNvSpPr txBox="1"/>
+          <p:nvPr/>
+        </p:nvSpPr>
+        <p:spPr>
+          <a:xfrm>
+            <a:off x="594360" y="1325880"/>
+            <a:ext cx="6766560" cy="365760"/>
+          </a:xfrm>
+          <a:prstGeom prst="rect">
+            <a:avLst/>
+          </a:prstGeom>
+          <a:noFill/>
+        </p:spPr>
+        <p:txBody>
+          <a:bodyPr wrap="square" lIns="45720" rIns="45720" tIns="18288" bIns="18288" anchor="t">
+            <a:noAutofit/>
+          </a:bodyPr>
+          <a:lstStyle/>
+          <a:p>
+            <a:pPr algn="l"/>
+            <a:r>
+              <a:rPr sz="1800" b="1">
+                <a:solidFill>
+                  <a:srgbClr val="2683C6"/>
+                </a:solidFill>
+                <a:latin typeface="Calibri"/>
+              </a:rPr>
+              <a:t>What the system must do</a:t>
+            </a:r>
+          </a:p>
+        </p:txBody>
+      </p:sp>
+      <p:sp>
+        <p:nvSpPr>
+          <p:cNvPr id="9" name="Function tile 1"/>
           <p:cNvSpPr/>
           <p:nvPr/>
         </p:nvSpPr>
         <p:spPr>
           <a:xfrm>
-            <a:off x="594360" y="1463040"/>
-            <a:ext cx="3520440" cy="2103120"/>
+            <a:off x="594360" y="1783080"/>
+            <a:ext cx="3337560" cy="1005840"/>
           </a:xfrm>
           <a:prstGeom prst="roundRect">
             <a:avLst>
-              <a:gd name="adj" fmla="val 8000"/>
+              <a:gd name="adj" fmla="val 10000"/>
             </a:avLst>
           </a:prstGeom>
           <a:solidFill>
-            <a:srgbClr val="F3F6F8"/>
+            <a:srgbClr val="EAF3FA"/>
           </a:solidFill>
           <a:ln>
             <a:noFill/>
@@ -22548,92 +23548,20 @@
       </p:sp>
       <p:sp>
         <p:nvSpPr>
-          <p:cNvPr id="9" name="TextBox 8"/>
-          <p:cNvSpPr txBox="1"/>
-          <p:nvPr/>
-        </p:nvSpPr>
-        <p:spPr>
-          <a:xfrm>
-            <a:off x="594360" y="1554480"/>
-            <a:ext cx="3520440" cy="1097280"/>
-          </a:xfrm>
-          <a:prstGeom prst="rect">
+          <p:cNvPr id="10" name="Oval 9"/>
+          <p:cNvSpPr/>
+          <p:nvPr/>
+        </p:nvSpPr>
+        <p:spPr>
+          <a:xfrm>
+            <a:off x="758952" y="2103120"/>
+            <a:ext cx="365760" cy="365760"/>
+          </a:xfrm>
+          <a:prstGeom prst="ellipse">
             <a:avLst/>
           </a:prstGeom>
-          <a:noFill/>
-        </p:spPr>
-        <p:txBody>
-          <a:bodyPr wrap="square" lIns="45720" rIns="45720" tIns="27432" bIns="27432" anchor="t">
-            <a:noAutofit/>
-          </a:bodyPr>
-          <a:lstStyle/>
-          <a:p>
-            <a:pPr algn="ctr"/>
-            <a:r>
-              <a:rPr sz="6600" b="1" i="0">
-                <a:solidFill>
-                  <a:srgbClr val="2683C6"/>
-                </a:solidFill>
-                <a:latin typeface="Calibri"/>
-              </a:rPr>
-              <a:t>12</a:t>
-            </a:r>
-          </a:p>
-        </p:txBody>
-      </p:sp>
-      <p:sp>
-        <p:nvSpPr>
-          <p:cNvPr id="10" name="TextBox 9"/>
-          <p:cNvSpPr txBox="1"/>
-          <p:nvPr/>
-        </p:nvSpPr>
-        <p:spPr>
-          <a:xfrm>
-            <a:off x="777240" y="2743200"/>
-            <a:ext cx="3154680" cy="731520"/>
-          </a:xfrm>
-          <a:prstGeom prst="rect">
-            <a:avLst/>
-          </a:prstGeom>
-          <a:noFill/>
-        </p:spPr>
-        <p:txBody>
-          <a:bodyPr wrap="square" lIns="45720" rIns="45720" tIns="27432" bIns="27432" anchor="t">
-            <a:noAutofit/>
-          </a:bodyPr>
-          <a:lstStyle/>
-          <a:p>
-            <a:pPr algn="ctr"/>
-            <a:r>
-              <a:rPr sz="1800" b="0" i="0">
-                <a:solidFill>
-                  <a:srgbClr val="335B74"/>
-                </a:solidFill>
-                <a:latin typeface="Calibri"/>
-              </a:rPr>
-              <a:t>functional requirements</a:t>
-            </a:r>
-          </a:p>
-        </p:txBody>
-      </p:sp>
-      <p:sp>
-        <p:nvSpPr>
-          <p:cNvPr id="11" name="Stat 2"/>
-          <p:cNvSpPr/>
-          <p:nvPr/>
-        </p:nvSpPr>
-        <p:spPr>
-          <a:xfrm>
-            <a:off x="4389120" y="1463040"/>
-            <a:ext cx="3520440" cy="2103120"/>
-          </a:xfrm>
-          <a:prstGeom prst="roundRect">
-            <a:avLst>
-              <a:gd name="adj" fmla="val 8000"/>
-            </a:avLst>
-          </a:prstGeom>
           <a:solidFill>
-            <a:srgbClr val="F3F6F8"/>
+            <a:srgbClr val="2683C6"/>
           </a:solidFill>
           <a:ln>
             <a:noFill/>
@@ -22664,14 +23592,49 @@
       </p:sp>
       <p:sp>
         <p:nvSpPr>
+          <p:cNvPr id="11" name="TextBox 10"/>
+          <p:cNvSpPr txBox="1"/>
+          <p:nvPr/>
+        </p:nvSpPr>
+        <p:spPr>
+          <a:xfrm>
+            <a:off x="1280160" y="1874519"/>
+            <a:ext cx="2606040" cy="411480"/>
+          </a:xfrm>
+          <a:prstGeom prst="rect">
+            <a:avLst/>
+          </a:prstGeom>
+          <a:noFill/>
+        </p:spPr>
+        <p:txBody>
+          <a:bodyPr wrap="square" lIns="45720" rIns="45720" tIns="18288" bIns="18288" anchor="t">
+            <a:noAutofit/>
+          </a:bodyPr>
+          <a:lstStyle/>
+          <a:p>
+            <a:pPr algn="l"/>
+            <a:r>
+              <a:rPr sz="1800" b="1">
+                <a:solidFill>
+                  <a:srgbClr val="335B74"/>
+                </a:solidFill>
+                <a:latin typeface="Calibri"/>
+              </a:rPr>
+              <a:t>Load a market</a:t>
+            </a:r>
+          </a:p>
+        </p:txBody>
+      </p:sp>
+      <p:sp>
+        <p:nvSpPr>
           <p:cNvPr id="12" name="TextBox 11"/>
           <p:cNvSpPr txBox="1"/>
           <p:nvPr/>
         </p:nvSpPr>
         <p:spPr>
           <a:xfrm>
-            <a:off x="4389120" y="1554480"/>
-            <a:ext cx="3520440" cy="1097280"/>
+            <a:off x="1280160" y="2286000"/>
+            <a:ext cx="2606040" cy="457200"/>
           </a:xfrm>
           <a:prstGeom prst="rect">
             <a:avLst/>
@@ -22679,77 +23642,42 @@
           <a:noFill/>
         </p:spPr>
         <p:txBody>
-          <a:bodyPr wrap="square" lIns="45720" rIns="45720" tIns="27432" bIns="27432" anchor="t">
+          <a:bodyPr wrap="square" lIns="45720" rIns="45720" tIns="18288" bIns="18288" anchor="t">
             <a:noAutofit/>
           </a:bodyPr>
           <a:lstStyle/>
           <a:p>
-            <a:pPr algn="ctr"/>
-            <a:r>
-              <a:rPr sz="6600" b="1" i="0">
-                <a:solidFill>
-                  <a:srgbClr val="D9731A"/>
-                </a:solidFill>
-                <a:latin typeface="Calibri"/>
-              </a:rPr>
-              <a:t>7</a:t>
-            </a:r>
-          </a:p>
-        </p:txBody>
-      </p:sp>
-      <p:sp>
-        <p:nvSpPr>
-          <p:cNvPr id="13" name="TextBox 12"/>
-          <p:cNvSpPr txBox="1"/>
-          <p:nvPr/>
-        </p:nvSpPr>
-        <p:spPr>
-          <a:xfrm>
-            <a:off x="4572000" y="2743200"/>
-            <a:ext cx="3154680" cy="731520"/>
-          </a:xfrm>
-          <a:prstGeom prst="rect">
-            <a:avLst/>
-          </a:prstGeom>
-          <a:noFill/>
-        </p:spPr>
-        <p:txBody>
-          <a:bodyPr wrap="square" lIns="45720" rIns="45720" tIns="27432" bIns="27432" anchor="t">
-            <a:noAutofit/>
-          </a:bodyPr>
-          <a:lstStyle/>
-          <a:p>
-            <a:pPr algn="ctr"/>
-            <a:r>
-              <a:rPr sz="1800" b="0" i="0">
+            <a:pPr algn="l"/>
+            <a:r>
+              <a:rPr sz="1400" b="0">
                 <a:solidFill>
                   <a:srgbClr val="335B74"/>
                 </a:solidFill>
                 <a:latin typeface="Calibri"/>
               </a:rPr>
-              <a:t>non-functional requirements</a:t>
-            </a:r>
-          </a:p>
-        </p:txBody>
-      </p:sp>
-      <p:sp>
-        <p:nvSpPr>
-          <p:cNvPr id="14" name="Stat 3"/>
+              <a:t>Simulated, or your own CSV prices</a:t>
+            </a:r>
+          </a:p>
+        </p:txBody>
+      </p:sp>
+      <p:sp>
+        <p:nvSpPr>
+          <p:cNvPr id="13" name="Function tile 2"/>
           <p:cNvSpPr/>
           <p:nvPr/>
         </p:nvSpPr>
         <p:spPr>
           <a:xfrm>
-            <a:off x="8183880" y="1463040"/>
-            <a:ext cx="3520440" cy="2103120"/>
+            <a:off x="4114800" y="1783080"/>
+            <a:ext cx="3337560" cy="1005840"/>
           </a:xfrm>
           <a:prstGeom prst="roundRect">
             <a:avLst>
-              <a:gd name="adj" fmla="val 8000"/>
+              <a:gd name="adj" fmla="val 10000"/>
             </a:avLst>
           </a:prstGeom>
           <a:solidFill>
-            <a:srgbClr val="F3F6F8"/>
+            <a:srgbClr val="EAF3FA"/>
           </a:solidFill>
           <a:ln>
             <a:noFill/>
@@ -22780,14 +23708,58 @@
       </p:sp>
       <p:sp>
         <p:nvSpPr>
+          <p:cNvPr id="14" name="Oval 13"/>
+          <p:cNvSpPr/>
+          <p:nvPr/>
+        </p:nvSpPr>
+        <p:spPr>
+          <a:xfrm>
+            <a:off x="4279392" y="2103120"/>
+            <a:ext cx="365760" cy="365760"/>
+          </a:xfrm>
+          <a:prstGeom prst="ellipse">
+            <a:avLst/>
+          </a:prstGeom>
+          <a:solidFill>
+            <a:srgbClr val="2683C6"/>
+          </a:solidFill>
+          <a:ln>
+            <a:noFill/>
+          </a:ln>
+          <a:effectLst/>
+        </p:spPr>
+        <p:style>
+          <a:lnRef idx="1">
+            <a:schemeClr val="accent1"/>
+          </a:lnRef>
+          <a:fillRef idx="3">
+            <a:schemeClr val="accent1"/>
+          </a:fillRef>
+          <a:effectRef idx="2">
+            <a:schemeClr val="accent1"/>
+          </a:effectRef>
+          <a:fontRef idx="minor">
+            <a:schemeClr val="lt1"/>
+          </a:fontRef>
+        </p:style>
+        <p:txBody>
+          <a:bodyPr rtlCol="0" anchor="ctr"/>
+          <a:lstStyle/>
+          <a:p>
+            <a:pPr algn="ctr"/>
+          </a:p>
+        </p:txBody>
+      </p:sp>
+      <p:sp>
+        <p:nvSpPr>
           <p:cNvPr id="15" name="TextBox 14"/>
           <p:cNvSpPr txBox="1"/>
           <p:nvPr/>
         </p:nvSpPr>
         <p:spPr>
           <a:xfrm>
-            <a:off x="8183880" y="1554480"/>
-            <a:ext cx="3520440" cy="1097280"/>
+            <a:off x="4800600" y="1874519"/>
+            <a:ext cx="2606040" cy="411480"/>
           </a:xfrm>
           <a:prstGeom prst="rect">
             <a:avLst/>
@@ -22795,20 +23767,20 @@
           <a:noFill/>
         </p:spPr>
         <p:txBody>
-          <a:bodyPr wrap="square" lIns="45720" rIns="45720" tIns="27432" bIns="27432" anchor="t">
+          <a:bodyPr wrap="square" lIns="45720" rIns="45720" tIns="18288" bIns="18288" anchor="t">
             <a:noAutofit/>
           </a:bodyPr>
           <a:lstStyle/>
           <a:p>
-            <a:pPr algn="ctr"/>
-            <a:r>
-              <a:rPr sz="6600" b="1" i="0">
-                <a:solidFill>
-                  <a:srgbClr val="42BA97"/>
-                </a:solidFill>
-                <a:latin typeface="Calibri"/>
-              </a:rPr>
-              <a:t>0</a:t>
+            <a:pPr algn="l"/>
+            <a:r>
+              <a:rPr sz="1800" b="1">
+                <a:solidFill>
+                  <a:srgbClr val="335B74"/>
+                </a:solidFill>
+                <a:latin typeface="Calibri"/>
+              </a:rPr>
+              <a:t>Set constraints</a:t>
             </a:r>
           </a:p>
         </p:txBody>
@@ -22821,8 +23793,8 @@
         </p:nvSpPr>
         <p:spPr>
           <a:xfrm>
-            <a:off x="8366760" y="2743200"/>
-            <a:ext cx="3154680" cy="731520"/>
+            <a:off x="4800600" y="2286000"/>
+            <a:ext cx="2606040" cy="457200"/>
           </a:xfrm>
           <a:prstGeom prst="rect">
             <a:avLst/>
@@ -22830,34 +23802,124 @@
           <a:noFill/>
         </p:spPr>
         <p:txBody>
-          <a:bodyPr wrap="square" lIns="45720" rIns="45720" tIns="27432" bIns="27432" anchor="t">
+          <a:bodyPr wrap="square" lIns="45720" rIns="45720" tIns="18288" bIns="18288" anchor="t">
             <a:noAutofit/>
           </a:bodyPr>
           <a:lstStyle/>
           <a:p>
+            <a:pPr algn="l"/>
+            <a:r>
+              <a:rPr sz="1400" b="0">
+                <a:solidFill>
+                  <a:srgbClr val="335B74"/>
+                </a:solidFill>
+                <a:latin typeface="Calibri"/>
+              </a:rPr>
+              <a:t>Cap, minimum size, holding limit</a:t>
+            </a:r>
+          </a:p>
+        </p:txBody>
+      </p:sp>
+      <p:sp>
+        <p:nvSpPr>
+          <p:cNvPr id="17" name="Function tile 3"/>
+          <p:cNvSpPr/>
+          <p:nvPr/>
+        </p:nvSpPr>
+        <p:spPr>
+          <a:xfrm>
+            <a:off x="594360" y="2926080"/>
+            <a:ext cx="3337560" cy="1005840"/>
+          </a:xfrm>
+          <a:prstGeom prst="roundRect">
+            <a:avLst>
+              <a:gd name="adj" fmla="val 10000"/>
+            </a:avLst>
+          </a:prstGeom>
+          <a:solidFill>
+            <a:srgbClr val="EAF3FA"/>
+          </a:solidFill>
+          <a:ln>
+            <a:noFill/>
+          </a:ln>
+          <a:effectLst/>
+        </p:spPr>
+        <p:style>
+          <a:lnRef idx="1">
+            <a:schemeClr val="accent1"/>
+          </a:lnRef>
+          <a:fillRef idx="3">
+            <a:schemeClr val="accent1"/>
+          </a:fillRef>
+          <a:effectRef idx="2">
+            <a:schemeClr val="accent1"/>
+          </a:effectRef>
+          <a:fontRef idx="minor">
+            <a:schemeClr val="lt1"/>
+          </a:fontRef>
+        </p:style>
+        <p:txBody>
+          <a:bodyPr rtlCol="0" anchor="ctr"/>
+          <a:lstStyle/>
+          <a:p>
             <a:pPr algn="ctr"/>
-            <a:r>
-              <a:rPr sz="1800" b="0" i="0">
-                <a:solidFill>
-                  <a:srgbClr val="335B74"/>
-                </a:solidFill>
-                <a:latin typeface="Calibri"/>
-              </a:rPr>
-              <a:t>INR software cost, all open source</a:t>
-            </a:r>
-          </a:p>
-        </p:txBody>
-      </p:sp>
-      <p:sp>
-        <p:nvSpPr>
-          <p:cNvPr id="17" name="TextBox 16"/>
+          </a:p>
+        </p:txBody>
+      </p:sp>
+      <p:sp>
+        <p:nvSpPr>
+          <p:cNvPr id="18" name="Oval 17"/>
+          <p:cNvSpPr/>
+          <p:nvPr/>
+        </p:nvSpPr>
+        <p:spPr>
+          <a:xfrm>
+            <a:off x="758952" y="3246120"/>
+            <a:ext cx="365760" cy="365760"/>
+          </a:xfrm>
+          <a:prstGeom prst="ellipse">
+            <a:avLst/>
+          </a:prstGeom>
+          <a:solidFill>
+            <a:srgbClr val="2683C6"/>
+          </a:solidFill>
+          <a:ln>
+            <a:noFill/>
+          </a:ln>
+          <a:effectLst/>
+        </p:spPr>
+        <p:style>
+          <a:lnRef idx="1">
+            <a:schemeClr val="accent1"/>
+          </a:lnRef>
+          <a:fillRef idx="3">
+            <a:schemeClr val="accent1"/>
+          </a:fillRef>
+          <a:effectRef idx="2">
+            <a:schemeClr val="accent1"/>
+          </a:effectRef>
+          <a:fontRef idx="minor">
+            <a:schemeClr val="lt1"/>
+          </a:fontRef>
+        </p:style>
+        <p:txBody>
+          <a:bodyPr rtlCol="0" anchor="ctr"/>
+          <a:lstStyle/>
+          <a:p>
+            <a:pPr algn="ctr"/>
+          </a:p>
+        </p:txBody>
+      </p:sp>
+      <p:sp>
+        <p:nvSpPr>
+          <p:cNvPr id="19" name="TextBox 18"/>
           <p:cNvSpPr txBox="1"/>
           <p:nvPr/>
         </p:nvSpPr>
         <p:spPr>
           <a:xfrm>
-            <a:off x="594360" y="3931920"/>
-            <a:ext cx="5486400" cy="365760"/>
+            <a:off x="1280160" y="3017520"/>
+            <a:ext cx="2606040" cy="411480"/>
           </a:xfrm>
           <a:prstGeom prst="rect">
             <a:avLst/>
@@ -22865,14 +23927,1239 @@
           <a:noFill/>
         </p:spPr>
         <p:txBody>
-          <a:bodyPr wrap="square" lIns="45720" rIns="45720" tIns="27432" bIns="27432" anchor="t">
+          <a:bodyPr wrap="square" lIns="45720" rIns="45720" tIns="18288" bIns="18288" anchor="t">
             <a:noAutofit/>
           </a:bodyPr>
           <a:lstStyle/>
           <a:p>
             <a:pPr algn="l"/>
             <a:r>
-              <a:rPr sz="1600" b="1" i="0">
+              <a:rPr sz="1800" b="1">
+                <a:solidFill>
+                  <a:srgbClr val="335B74"/>
+                </a:solidFill>
+                <a:latin typeface="Calibri"/>
+              </a:rPr>
+              <a:t>Run two optimisers</a:t>
+            </a:r>
+          </a:p>
+        </p:txBody>
+      </p:sp>
+      <p:sp>
+        <p:nvSpPr>
+          <p:cNvPr id="20" name="TextBox 19"/>
+          <p:cNvSpPr txBox="1"/>
+          <p:nvPr/>
+        </p:nvSpPr>
+        <p:spPr>
+          <a:xfrm>
+            <a:off x="1280160" y="3429000"/>
+            <a:ext cx="2606040" cy="457200"/>
+          </a:xfrm>
+          <a:prstGeom prst="rect">
+            <a:avLst/>
+          </a:prstGeom>
+          <a:noFill/>
+        </p:spPr>
+        <p:txBody>
+          <a:bodyPr wrap="square" lIns="45720" rIns="45720" tIns="18288" bIns="18288" anchor="t">
+            <a:noAutofit/>
+          </a:bodyPr>
+          <a:lstStyle/>
+          <a:p>
+            <a:pPr algn="l"/>
+            <a:r>
+              <a:rPr sz="1400" b="0">
+                <a:solidFill>
+                  <a:srgbClr val="335B74"/>
+                </a:solidFill>
+                <a:latin typeface="Calibri"/>
+              </a:rPr>
+              <a:t>MOPSO and NSGA-II side by side</a:t>
+            </a:r>
+          </a:p>
+        </p:txBody>
+      </p:sp>
+      <p:sp>
+        <p:nvSpPr>
+          <p:cNvPr id="21" name="Function tile 4"/>
+          <p:cNvSpPr/>
+          <p:nvPr/>
+        </p:nvSpPr>
+        <p:spPr>
+          <a:xfrm>
+            <a:off x="4114800" y="2926080"/>
+            <a:ext cx="3337560" cy="1005840"/>
+          </a:xfrm>
+          <a:prstGeom prst="roundRect">
+            <a:avLst>
+              <a:gd name="adj" fmla="val 10000"/>
+            </a:avLst>
+          </a:prstGeom>
+          <a:solidFill>
+            <a:srgbClr val="EAF3FA"/>
+          </a:solidFill>
+          <a:ln>
+            <a:noFill/>
+          </a:ln>
+          <a:effectLst/>
+        </p:spPr>
+        <p:style>
+          <a:lnRef idx="1">
+            <a:schemeClr val="accent1"/>
+          </a:lnRef>
+          <a:fillRef idx="3">
+            <a:schemeClr val="accent1"/>
+          </a:fillRef>
+          <a:effectRef idx="2">
+            <a:schemeClr val="accent1"/>
+          </a:effectRef>
+          <a:fontRef idx="minor">
+            <a:schemeClr val="lt1"/>
+          </a:fontRef>
+        </p:style>
+        <p:txBody>
+          <a:bodyPr rtlCol="0" anchor="ctr"/>
+          <a:lstStyle/>
+          <a:p>
+            <a:pPr algn="ctr"/>
+          </a:p>
+        </p:txBody>
+      </p:sp>
+      <p:sp>
+        <p:nvSpPr>
+          <p:cNvPr id="22" name="Oval 21"/>
+          <p:cNvSpPr/>
+          <p:nvPr/>
+        </p:nvSpPr>
+        <p:spPr>
+          <a:xfrm>
+            <a:off x="4279392" y="3246120"/>
+            <a:ext cx="365760" cy="365760"/>
+          </a:xfrm>
+          <a:prstGeom prst="ellipse">
+            <a:avLst/>
+          </a:prstGeom>
+          <a:solidFill>
+            <a:srgbClr val="2683C6"/>
+          </a:solidFill>
+          <a:ln>
+            <a:noFill/>
+          </a:ln>
+          <a:effectLst/>
+        </p:spPr>
+        <p:style>
+          <a:lnRef idx="1">
+            <a:schemeClr val="accent1"/>
+          </a:lnRef>
+          <a:fillRef idx="3">
+            <a:schemeClr val="accent1"/>
+          </a:fillRef>
+          <a:effectRef idx="2">
+            <a:schemeClr val="accent1"/>
+          </a:effectRef>
+          <a:fontRef idx="minor">
+            <a:schemeClr val="lt1"/>
+          </a:fontRef>
+        </p:style>
+        <p:txBody>
+          <a:bodyPr rtlCol="0" anchor="ctr"/>
+          <a:lstStyle/>
+          <a:p>
+            <a:pPr algn="ctr"/>
+          </a:p>
+        </p:txBody>
+      </p:sp>
+      <p:sp>
+        <p:nvSpPr>
+          <p:cNvPr id="23" name="TextBox 22"/>
+          <p:cNvSpPr txBox="1"/>
+          <p:nvPr/>
+        </p:nvSpPr>
+        <p:spPr>
+          <a:xfrm>
+            <a:off x="4800600" y="3017520"/>
+            <a:ext cx="2606040" cy="411480"/>
+          </a:xfrm>
+          <a:prstGeom prst="rect">
+            <a:avLst/>
+          </a:prstGeom>
+          <a:noFill/>
+        </p:spPr>
+        <p:txBody>
+          <a:bodyPr wrap="square" lIns="45720" rIns="45720" tIns="18288" bIns="18288" anchor="t">
+            <a:noAutofit/>
+          </a:bodyPr>
+          <a:lstStyle/>
+          <a:p>
+            <a:pPr algn="l"/>
+            <a:r>
+              <a:rPr sz="1800" b="1">
+                <a:solidFill>
+                  <a:srgbClr val="335B74"/>
+                </a:solidFill>
+                <a:latin typeface="Calibri"/>
+              </a:rPr>
+              <a:t>Watch progress</a:t>
+            </a:r>
+          </a:p>
+        </p:txBody>
+      </p:sp>
+      <p:sp>
+        <p:nvSpPr>
+          <p:cNvPr id="24" name="TextBox 23"/>
+          <p:cNvSpPr txBox="1"/>
+          <p:nvPr/>
+        </p:nvSpPr>
+        <p:spPr>
+          <a:xfrm>
+            <a:off x="4800600" y="3429000"/>
+            <a:ext cx="2606040" cy="457200"/>
+          </a:xfrm>
+          <a:prstGeom prst="rect">
+            <a:avLst/>
+          </a:prstGeom>
+          <a:noFill/>
+        </p:spPr>
+        <p:txBody>
+          <a:bodyPr wrap="square" lIns="45720" rIns="45720" tIns="18288" bIns="18288" anchor="t">
+            <a:noAutofit/>
+          </a:bodyPr>
+          <a:lstStyle/>
+          <a:p>
+            <a:pPr algn="l"/>
+            <a:r>
+              <a:rPr sz="1400" b="0">
+                <a:solidFill>
+                  <a:srgbClr val="335B74"/>
+                </a:solidFill>
+                <a:latin typeface="Calibri"/>
+              </a:rPr>
+              <a:t>Live populations and a Stop button</a:t>
+            </a:r>
+          </a:p>
+        </p:txBody>
+      </p:sp>
+      <p:sp>
+        <p:nvSpPr>
+          <p:cNvPr id="25" name="Function tile 5"/>
+          <p:cNvSpPr/>
+          <p:nvPr/>
+        </p:nvSpPr>
+        <p:spPr>
+          <a:xfrm>
+            <a:off x="594360" y="4069080"/>
+            <a:ext cx="3337560" cy="1005840"/>
+          </a:xfrm>
+          <a:prstGeom prst="roundRect">
+            <a:avLst>
+              <a:gd name="adj" fmla="val 10000"/>
+            </a:avLst>
+          </a:prstGeom>
+          <a:solidFill>
+            <a:srgbClr val="EAF3FA"/>
+          </a:solidFill>
+          <a:ln>
+            <a:noFill/>
+          </a:ln>
+          <a:effectLst/>
+        </p:spPr>
+        <p:style>
+          <a:lnRef idx="1">
+            <a:schemeClr val="accent1"/>
+          </a:lnRef>
+          <a:fillRef idx="3">
+            <a:schemeClr val="accent1"/>
+          </a:fillRef>
+          <a:effectRef idx="2">
+            <a:schemeClr val="accent1"/>
+          </a:effectRef>
+          <a:fontRef idx="minor">
+            <a:schemeClr val="lt1"/>
+          </a:fontRef>
+        </p:style>
+        <p:txBody>
+          <a:bodyPr rtlCol="0" anchor="ctr"/>
+          <a:lstStyle/>
+          <a:p>
+            <a:pPr algn="ctr"/>
+          </a:p>
+        </p:txBody>
+      </p:sp>
+      <p:sp>
+        <p:nvSpPr>
+          <p:cNvPr id="26" name="Oval 25"/>
+          <p:cNvSpPr/>
+          <p:nvPr/>
+        </p:nvSpPr>
+        <p:spPr>
+          <a:xfrm>
+            <a:off x="758952" y="4389120"/>
+            <a:ext cx="365760" cy="365760"/>
+          </a:xfrm>
+          <a:prstGeom prst="ellipse">
+            <a:avLst/>
+          </a:prstGeom>
+          <a:solidFill>
+            <a:srgbClr val="2683C6"/>
+          </a:solidFill>
+          <a:ln>
+            <a:noFill/>
+          </a:ln>
+          <a:effectLst/>
+        </p:spPr>
+        <p:style>
+          <a:lnRef idx="1">
+            <a:schemeClr val="accent1"/>
+          </a:lnRef>
+          <a:fillRef idx="3">
+            <a:schemeClr val="accent1"/>
+          </a:fillRef>
+          <a:effectRef idx="2">
+            <a:schemeClr val="accent1"/>
+          </a:effectRef>
+          <a:fontRef idx="minor">
+            <a:schemeClr val="lt1"/>
+          </a:fontRef>
+        </p:style>
+        <p:txBody>
+          <a:bodyPr rtlCol="0" anchor="ctr"/>
+          <a:lstStyle/>
+          <a:p>
+            <a:pPr algn="ctr"/>
+          </a:p>
+        </p:txBody>
+      </p:sp>
+      <p:sp>
+        <p:nvSpPr>
+          <p:cNvPr id="27" name="TextBox 26"/>
+          <p:cNvSpPr txBox="1"/>
+          <p:nvPr/>
+        </p:nvSpPr>
+        <p:spPr>
+          <a:xfrm>
+            <a:off x="1280160" y="4160520"/>
+            <a:ext cx="2606040" cy="411480"/>
+          </a:xfrm>
+          <a:prstGeom prst="rect">
+            <a:avLst/>
+          </a:prstGeom>
+          <a:noFill/>
+        </p:spPr>
+        <p:txBody>
+          <a:bodyPr wrap="square" lIns="45720" rIns="45720" tIns="18288" bIns="18288" anchor="t">
+            <a:noAutofit/>
+          </a:bodyPr>
+          <a:lstStyle/>
+          <a:p>
+            <a:pPr algn="l"/>
+            <a:r>
+              <a:rPr sz="1800" b="1">
+                <a:solidFill>
+                  <a:srgbClr val="335B74"/>
+                </a:solidFill>
+                <a:latin typeface="Calibri"/>
+              </a:rPr>
+              <a:t>Inspect portfolios</a:t>
+            </a:r>
+          </a:p>
+        </p:txBody>
+      </p:sp>
+      <p:sp>
+        <p:nvSpPr>
+          <p:cNvPr id="28" name="TextBox 27"/>
+          <p:cNvSpPr txBox="1"/>
+          <p:nvPr/>
+        </p:nvSpPr>
+        <p:spPr>
+          <a:xfrm>
+            <a:off x="1280160" y="4572000"/>
+            <a:ext cx="2606040" cy="457200"/>
+          </a:xfrm>
+          <a:prstGeom prst="rect">
+            <a:avLst/>
+          </a:prstGeom>
+          <a:noFill/>
+        </p:spPr>
+        <p:txBody>
+          <a:bodyPr wrap="square" lIns="45720" rIns="45720" tIns="18288" bIns="18288" anchor="t">
+            <a:noAutofit/>
+          </a:bodyPr>
+          <a:lstStyle/>
+          <a:p>
+            <a:pPr algn="l"/>
+            <a:r>
+              <a:rPr sz="1400" b="0">
+                <a:solidFill>
+                  <a:srgbClr val="335B74"/>
+                </a:solidFill>
+                <a:latin typeface="Calibri"/>
+              </a:rPr>
+              <a:t>Weights, training and held-out results</a:t>
+            </a:r>
+          </a:p>
+        </p:txBody>
+      </p:sp>
+      <p:sp>
+        <p:nvSpPr>
+          <p:cNvPr id="29" name="Function tile 6"/>
+          <p:cNvSpPr/>
+          <p:nvPr/>
+        </p:nvSpPr>
+        <p:spPr>
+          <a:xfrm>
+            <a:off x="4114800" y="4069080"/>
+            <a:ext cx="3337560" cy="1005840"/>
+          </a:xfrm>
+          <a:prstGeom prst="roundRect">
+            <a:avLst>
+              <a:gd name="adj" fmla="val 10000"/>
+            </a:avLst>
+          </a:prstGeom>
+          <a:solidFill>
+            <a:srgbClr val="EAF3FA"/>
+          </a:solidFill>
+          <a:ln>
+            <a:noFill/>
+          </a:ln>
+          <a:effectLst/>
+        </p:spPr>
+        <p:style>
+          <a:lnRef idx="1">
+            <a:schemeClr val="accent1"/>
+          </a:lnRef>
+          <a:fillRef idx="3">
+            <a:schemeClr val="accent1"/>
+          </a:fillRef>
+          <a:effectRef idx="2">
+            <a:schemeClr val="accent1"/>
+          </a:effectRef>
+          <a:fontRef idx="minor">
+            <a:schemeClr val="lt1"/>
+          </a:fontRef>
+        </p:style>
+        <p:txBody>
+          <a:bodyPr rtlCol="0" anchor="ctr"/>
+          <a:lstStyle/>
+          <a:p>
+            <a:pPr algn="ctr"/>
+          </a:p>
+        </p:txBody>
+      </p:sp>
+      <p:sp>
+        <p:nvSpPr>
+          <p:cNvPr id="30" name="Oval 29"/>
+          <p:cNvSpPr/>
+          <p:nvPr/>
+        </p:nvSpPr>
+        <p:spPr>
+          <a:xfrm>
+            <a:off x="4279392" y="4389120"/>
+            <a:ext cx="365760" cy="365760"/>
+          </a:xfrm>
+          <a:prstGeom prst="ellipse">
+            <a:avLst/>
+          </a:prstGeom>
+          <a:solidFill>
+            <a:srgbClr val="2683C6"/>
+          </a:solidFill>
+          <a:ln>
+            <a:noFill/>
+          </a:ln>
+          <a:effectLst/>
+        </p:spPr>
+        <p:style>
+          <a:lnRef idx="1">
+            <a:schemeClr val="accent1"/>
+          </a:lnRef>
+          <a:fillRef idx="3">
+            <a:schemeClr val="accent1"/>
+          </a:fillRef>
+          <a:effectRef idx="2">
+            <a:schemeClr val="accent1"/>
+          </a:effectRef>
+          <a:fontRef idx="minor">
+            <a:schemeClr val="lt1"/>
+          </a:fontRef>
+        </p:style>
+        <p:txBody>
+          <a:bodyPr rtlCol="0" anchor="ctr"/>
+          <a:lstStyle/>
+          <a:p>
+            <a:pPr algn="ctr"/>
+          </a:p>
+        </p:txBody>
+      </p:sp>
+      <p:sp>
+        <p:nvSpPr>
+          <p:cNvPr id="31" name="TextBox 30"/>
+          <p:cNvSpPr txBox="1"/>
+          <p:nvPr/>
+        </p:nvSpPr>
+        <p:spPr>
+          <a:xfrm>
+            <a:off x="4800600" y="4160520"/>
+            <a:ext cx="2606040" cy="411480"/>
+          </a:xfrm>
+          <a:prstGeom prst="rect">
+            <a:avLst/>
+          </a:prstGeom>
+          <a:noFill/>
+        </p:spPr>
+        <p:txBody>
+          <a:bodyPr wrap="square" lIns="45720" rIns="45720" tIns="18288" bIns="18288" anchor="t">
+            <a:noAutofit/>
+          </a:bodyPr>
+          <a:lstStyle/>
+          <a:p>
+            <a:pPr algn="l"/>
+            <a:r>
+              <a:rPr sz="1800" b="1">
+                <a:solidFill>
+                  <a:srgbClr val="335B74"/>
+                </a:solidFill>
+                <a:latin typeface="Calibri"/>
+              </a:rPr>
+              <a:t>Compare methods</a:t>
+            </a:r>
+          </a:p>
+        </p:txBody>
+      </p:sp>
+      <p:sp>
+        <p:nvSpPr>
+          <p:cNvPr id="32" name="TextBox 31"/>
+          <p:cNvSpPr txBox="1"/>
+          <p:nvPr/>
+        </p:nvSpPr>
+        <p:spPr>
+          <a:xfrm>
+            <a:off x="4800600" y="4572000"/>
+            <a:ext cx="2606040" cy="457200"/>
+          </a:xfrm>
+          <a:prstGeom prst="rect">
+            <a:avLst/>
+          </a:prstGeom>
+          <a:noFill/>
+        </p:spPr>
+        <p:txBody>
+          <a:bodyPr wrap="square" lIns="45720" rIns="45720" tIns="18288" bIns="18288" anchor="t">
+            <a:noAutofit/>
+          </a:bodyPr>
+          <a:lstStyle/>
+          <a:p>
+            <a:pPr algn="l"/>
+            <a:r>
+              <a:rPr sz="1400" b="0">
+                <a:solidFill>
+                  <a:srgbClr val="335B74"/>
+                </a:solidFill>
+                <a:latin typeface="Calibri"/>
+              </a:rPr>
+              <a:t>Hypervolume against random search</a:t>
+            </a:r>
+          </a:p>
+        </p:txBody>
+      </p:sp>
+      <p:sp>
+        <p:nvSpPr>
+          <p:cNvPr id="33" name="TextBox 32"/>
+          <p:cNvSpPr txBox="1"/>
+          <p:nvPr/>
+        </p:nvSpPr>
+        <p:spPr>
+          <a:xfrm>
+            <a:off x="7818120" y="1325880"/>
+            <a:ext cx="3840480" cy="365760"/>
+          </a:xfrm>
+          <a:prstGeom prst="rect">
+            <a:avLst/>
+          </a:prstGeom>
+          <a:noFill/>
+        </p:spPr>
+        <p:txBody>
+          <a:bodyPr wrap="square" lIns="45720" rIns="45720" tIns="18288" bIns="18288" anchor="t">
+            <a:noAutofit/>
+          </a:bodyPr>
+          <a:lstStyle/>
+          <a:p>
+            <a:pPr algn="l"/>
+            <a:r>
+              <a:rPr sz="1800" b="1">
+                <a:solidFill>
+                  <a:srgbClr val="D9731A"/>
+                </a:solidFill>
+                <a:latin typeface="Calibri"/>
+              </a:rPr>
+              <a:t>Quality targets</a:t>
+            </a:r>
+          </a:p>
+        </p:txBody>
+      </p:sp>
+      <p:sp>
+        <p:nvSpPr>
+          <p:cNvPr id="34" name="Quality tile 1"/>
+          <p:cNvSpPr/>
+          <p:nvPr/>
+        </p:nvSpPr>
+        <p:spPr>
+          <a:xfrm>
+            <a:off x="7818120" y="1783080"/>
+            <a:ext cx="3886200" cy="749808"/>
+          </a:xfrm>
+          <a:prstGeom prst="roundRect">
+            <a:avLst>
+              <a:gd name="adj" fmla="val 10000"/>
+            </a:avLst>
+          </a:prstGeom>
+          <a:solidFill>
+            <a:srgbClr val="FBEFE3"/>
+          </a:solidFill>
+          <a:ln>
+            <a:noFill/>
+          </a:ln>
+          <a:effectLst/>
+        </p:spPr>
+        <p:style>
+          <a:lnRef idx="1">
+            <a:schemeClr val="accent1"/>
+          </a:lnRef>
+          <a:fillRef idx="3">
+            <a:schemeClr val="accent1"/>
+          </a:fillRef>
+          <a:effectRef idx="2">
+            <a:schemeClr val="accent1"/>
+          </a:effectRef>
+          <a:fontRef idx="minor">
+            <a:schemeClr val="lt1"/>
+          </a:fontRef>
+        </p:style>
+        <p:txBody>
+          <a:bodyPr rtlCol="0" anchor="ctr"/>
+          <a:lstStyle/>
+          <a:p>
+            <a:pPr algn="ctr"/>
+          </a:p>
+        </p:txBody>
+      </p:sp>
+      <p:sp>
+        <p:nvSpPr>
+          <p:cNvPr id="35" name="Oval 34"/>
+          <p:cNvSpPr/>
+          <p:nvPr/>
+        </p:nvSpPr>
+        <p:spPr>
+          <a:xfrm>
+            <a:off x="7973568" y="1975104"/>
+            <a:ext cx="365760" cy="365760"/>
+          </a:xfrm>
+          <a:prstGeom prst="ellipse">
+            <a:avLst/>
+          </a:prstGeom>
+          <a:solidFill>
+            <a:srgbClr val="D9731A"/>
+          </a:solidFill>
+          <a:ln>
+            <a:noFill/>
+          </a:ln>
+          <a:effectLst/>
+        </p:spPr>
+        <p:style>
+          <a:lnRef idx="1">
+            <a:schemeClr val="accent1"/>
+          </a:lnRef>
+          <a:fillRef idx="3">
+            <a:schemeClr val="accent1"/>
+          </a:fillRef>
+          <a:effectRef idx="2">
+            <a:schemeClr val="accent1"/>
+          </a:effectRef>
+          <a:fontRef idx="minor">
+            <a:schemeClr val="lt1"/>
+          </a:fontRef>
+        </p:style>
+        <p:txBody>
+          <a:bodyPr rtlCol="0" anchor="ctr"/>
+          <a:lstStyle/>
+          <a:p>
+            <a:pPr algn="ctr"/>
+          </a:p>
+        </p:txBody>
+      </p:sp>
+      <p:sp>
+        <p:nvSpPr>
+          <p:cNvPr id="36" name="TextBox 35"/>
+          <p:cNvSpPr txBox="1"/>
+          <p:nvPr/>
+        </p:nvSpPr>
+        <p:spPr>
+          <a:xfrm>
+            <a:off x="8503920" y="1837943"/>
+            <a:ext cx="3108960" cy="365760"/>
+          </a:xfrm>
+          <a:prstGeom prst="rect">
+            <a:avLst/>
+          </a:prstGeom>
+          <a:noFill/>
+        </p:spPr>
+        <p:txBody>
+          <a:bodyPr wrap="square" lIns="45720" rIns="45720" tIns="18288" bIns="18288" anchor="t">
+            <a:noAutofit/>
+          </a:bodyPr>
+          <a:lstStyle/>
+          <a:p>
+            <a:pPr algn="l"/>
+            <a:r>
+              <a:rPr sz="1800" b="1">
+                <a:solidFill>
+                  <a:srgbClr val="335B74"/>
+                </a:solidFill>
+                <a:latin typeface="Calibri"/>
+              </a:rPr>
+              <a:t>Correct</a:t>
+            </a:r>
+          </a:p>
+        </p:txBody>
+      </p:sp>
+      <p:sp>
+        <p:nvSpPr>
+          <p:cNvPr id="37" name="TextBox 36"/>
+          <p:cNvSpPr txBox="1"/>
+          <p:nvPr/>
+        </p:nvSpPr>
+        <p:spPr>
+          <a:xfrm>
+            <a:off x="8503920" y="2185416"/>
+            <a:ext cx="3108960" cy="320040"/>
+          </a:xfrm>
+          <a:prstGeom prst="rect">
+            <a:avLst/>
+          </a:prstGeom>
+          <a:noFill/>
+        </p:spPr>
+        <p:txBody>
+          <a:bodyPr wrap="square" lIns="45720" rIns="45720" tIns="18288" bIns="18288" anchor="t">
+            <a:noAutofit/>
+          </a:bodyPr>
+          <a:lstStyle/>
+          <a:p>
+            <a:pPr algn="l"/>
+            <a:r>
+              <a:rPr sz="1400" b="0">
+                <a:solidFill>
+                  <a:srgbClr val="335B74"/>
+                </a:solidFill>
+                <a:latin typeface="Calibri"/>
+              </a:rPr>
+              <a:t>Every constraint always met</a:t>
+            </a:r>
+          </a:p>
+        </p:txBody>
+      </p:sp>
+      <p:sp>
+        <p:nvSpPr>
+          <p:cNvPr id="38" name="Quality tile 2"/>
+          <p:cNvSpPr/>
+          <p:nvPr/>
+        </p:nvSpPr>
+        <p:spPr>
+          <a:xfrm>
+            <a:off x="7818120" y="2651760"/>
+            <a:ext cx="3886200" cy="749808"/>
+          </a:xfrm>
+          <a:prstGeom prst="roundRect">
+            <a:avLst>
+              <a:gd name="adj" fmla="val 10000"/>
+            </a:avLst>
+          </a:prstGeom>
+          <a:solidFill>
+            <a:srgbClr val="FBEFE3"/>
+          </a:solidFill>
+          <a:ln>
+            <a:noFill/>
+          </a:ln>
+          <a:effectLst/>
+        </p:spPr>
+        <p:style>
+          <a:lnRef idx="1">
+            <a:schemeClr val="accent1"/>
+          </a:lnRef>
+          <a:fillRef idx="3">
+            <a:schemeClr val="accent1"/>
+          </a:fillRef>
+          <a:effectRef idx="2">
+            <a:schemeClr val="accent1"/>
+          </a:effectRef>
+          <a:fontRef idx="minor">
+            <a:schemeClr val="lt1"/>
+          </a:fontRef>
+        </p:style>
+        <p:txBody>
+          <a:bodyPr rtlCol="0" anchor="ctr"/>
+          <a:lstStyle/>
+          <a:p>
+            <a:pPr algn="ctr"/>
+          </a:p>
+        </p:txBody>
+      </p:sp>
+      <p:sp>
+        <p:nvSpPr>
+          <p:cNvPr id="39" name="Oval 38"/>
+          <p:cNvSpPr/>
+          <p:nvPr/>
+        </p:nvSpPr>
+        <p:spPr>
+          <a:xfrm>
+            <a:off x="7973568" y="2843784"/>
+            <a:ext cx="365760" cy="365760"/>
+          </a:xfrm>
+          <a:prstGeom prst="ellipse">
+            <a:avLst/>
+          </a:prstGeom>
+          <a:solidFill>
+            <a:srgbClr val="D9731A"/>
+          </a:solidFill>
+          <a:ln>
+            <a:noFill/>
+          </a:ln>
+          <a:effectLst/>
+        </p:spPr>
+        <p:style>
+          <a:lnRef idx="1">
+            <a:schemeClr val="accent1"/>
+          </a:lnRef>
+          <a:fillRef idx="3">
+            <a:schemeClr val="accent1"/>
+          </a:fillRef>
+          <a:effectRef idx="2">
+            <a:schemeClr val="accent1"/>
+          </a:effectRef>
+          <a:fontRef idx="minor">
+            <a:schemeClr val="lt1"/>
+          </a:fontRef>
+        </p:style>
+        <p:txBody>
+          <a:bodyPr rtlCol="0" anchor="ctr"/>
+          <a:lstStyle/>
+          <a:p>
+            <a:pPr algn="ctr"/>
+          </a:p>
+        </p:txBody>
+      </p:sp>
+      <p:sp>
+        <p:nvSpPr>
+          <p:cNvPr id="40" name="TextBox 39"/>
+          <p:cNvSpPr txBox="1"/>
+          <p:nvPr/>
+        </p:nvSpPr>
+        <p:spPr>
+          <a:xfrm>
+            <a:off x="8503920" y="2706624"/>
+            <a:ext cx="3108960" cy="365760"/>
+          </a:xfrm>
+          <a:prstGeom prst="rect">
+            <a:avLst/>
+          </a:prstGeom>
+          <a:noFill/>
+        </p:spPr>
+        <p:txBody>
+          <a:bodyPr wrap="square" lIns="45720" rIns="45720" tIns="18288" bIns="18288" anchor="t">
+            <a:noAutofit/>
+          </a:bodyPr>
+          <a:lstStyle/>
+          <a:p>
+            <a:pPr algn="l"/>
+            <a:r>
+              <a:rPr sz="1800" b="1">
+                <a:solidFill>
+                  <a:srgbClr val="335B74"/>
+                </a:solidFill>
+                <a:latin typeface="Calibri"/>
+              </a:rPr>
+              <a:t>Reproducible</a:t>
+            </a:r>
+          </a:p>
+        </p:txBody>
+      </p:sp>
+      <p:sp>
+        <p:nvSpPr>
+          <p:cNvPr id="41" name="TextBox 40"/>
+          <p:cNvSpPr txBox="1"/>
+          <p:nvPr/>
+        </p:nvSpPr>
+        <p:spPr>
+          <a:xfrm>
+            <a:off x="8503920" y="3054096"/>
+            <a:ext cx="3108960" cy="320040"/>
+          </a:xfrm>
+          <a:prstGeom prst="rect">
+            <a:avLst/>
+          </a:prstGeom>
+          <a:noFill/>
+        </p:spPr>
+        <p:txBody>
+          <a:bodyPr wrap="square" lIns="45720" rIns="45720" tIns="18288" bIns="18288" anchor="t">
+            <a:noAutofit/>
+          </a:bodyPr>
+          <a:lstStyle/>
+          <a:p>
+            <a:pPr algn="l"/>
+            <a:r>
+              <a:rPr sz="1400" b="0">
+                <a:solidFill>
+                  <a:srgbClr val="335B74"/>
+                </a:solidFill>
+                <a:latin typeface="Calibri"/>
+              </a:rPr>
+              <a:t>Same seed, same front</a:t>
+            </a:r>
+          </a:p>
+        </p:txBody>
+      </p:sp>
+      <p:sp>
+        <p:nvSpPr>
+          <p:cNvPr id="42" name="Quality tile 3"/>
+          <p:cNvSpPr/>
+          <p:nvPr/>
+        </p:nvSpPr>
+        <p:spPr>
+          <a:xfrm>
+            <a:off x="7818120" y="3520439"/>
+            <a:ext cx="3886200" cy="749808"/>
+          </a:xfrm>
+          <a:prstGeom prst="roundRect">
+            <a:avLst>
+              <a:gd name="adj" fmla="val 10000"/>
+            </a:avLst>
+          </a:prstGeom>
+          <a:solidFill>
+            <a:srgbClr val="FBEFE3"/>
+          </a:solidFill>
+          <a:ln>
+            <a:noFill/>
+          </a:ln>
+          <a:effectLst/>
+        </p:spPr>
+        <p:style>
+          <a:lnRef idx="1">
+            <a:schemeClr val="accent1"/>
+          </a:lnRef>
+          <a:fillRef idx="3">
+            <a:schemeClr val="accent1"/>
+          </a:fillRef>
+          <a:effectRef idx="2">
+            <a:schemeClr val="accent1"/>
+          </a:effectRef>
+          <a:fontRef idx="minor">
+            <a:schemeClr val="lt1"/>
+          </a:fontRef>
+        </p:style>
+        <p:txBody>
+          <a:bodyPr rtlCol="0" anchor="ctr"/>
+          <a:lstStyle/>
+          <a:p>
+            <a:pPr algn="ctr"/>
+          </a:p>
+        </p:txBody>
+      </p:sp>
+      <p:sp>
+        <p:nvSpPr>
+          <p:cNvPr id="43" name="Oval 42"/>
+          <p:cNvSpPr/>
+          <p:nvPr/>
+        </p:nvSpPr>
+        <p:spPr>
+          <a:xfrm>
+            <a:off x="7973568" y="3712463"/>
+            <a:ext cx="365760" cy="365760"/>
+          </a:xfrm>
+          <a:prstGeom prst="ellipse">
+            <a:avLst/>
+          </a:prstGeom>
+          <a:solidFill>
+            <a:srgbClr val="D9731A"/>
+          </a:solidFill>
+          <a:ln>
+            <a:noFill/>
+          </a:ln>
+          <a:effectLst/>
+        </p:spPr>
+        <p:style>
+          <a:lnRef idx="1">
+            <a:schemeClr val="accent1"/>
+          </a:lnRef>
+          <a:fillRef idx="3">
+            <a:schemeClr val="accent1"/>
+          </a:fillRef>
+          <a:effectRef idx="2">
+            <a:schemeClr val="accent1"/>
+          </a:effectRef>
+          <a:fontRef idx="minor">
+            <a:schemeClr val="lt1"/>
+          </a:fontRef>
+        </p:style>
+        <p:txBody>
+          <a:bodyPr rtlCol="0" anchor="ctr"/>
+          <a:lstStyle/>
+          <a:p>
+            <a:pPr algn="ctr"/>
+          </a:p>
+        </p:txBody>
+      </p:sp>
+      <p:sp>
+        <p:nvSpPr>
+          <p:cNvPr id="44" name="TextBox 43"/>
+          <p:cNvSpPr txBox="1"/>
+          <p:nvPr/>
+        </p:nvSpPr>
+        <p:spPr>
+          <a:xfrm>
+            <a:off x="8503920" y="3575303"/>
+            <a:ext cx="3108960" cy="365760"/>
+          </a:xfrm>
+          <a:prstGeom prst="rect">
+            <a:avLst/>
+          </a:prstGeom>
+          <a:noFill/>
+        </p:spPr>
+        <p:txBody>
+          <a:bodyPr wrap="square" lIns="45720" rIns="45720" tIns="18288" bIns="18288" anchor="t">
+            <a:noAutofit/>
+          </a:bodyPr>
+          <a:lstStyle/>
+          <a:p>
+            <a:pPr algn="l"/>
+            <a:r>
+              <a:rPr sz="1800" b="1">
+                <a:solidFill>
+                  <a:srgbClr val="335B74"/>
+                </a:solidFill>
+                <a:latin typeface="Calibri"/>
+              </a:rPr>
+              <a:t>Fast</a:t>
+            </a:r>
+          </a:p>
+        </p:txBody>
+      </p:sp>
+      <p:sp>
+        <p:nvSpPr>
+          <p:cNvPr id="45" name="TextBox 44"/>
+          <p:cNvSpPr txBox="1"/>
+          <p:nvPr/>
+        </p:nvSpPr>
+        <p:spPr>
+          <a:xfrm>
+            <a:off x="8503920" y="3922776"/>
+            <a:ext cx="3108960" cy="320040"/>
+          </a:xfrm>
+          <a:prstGeom prst="rect">
+            <a:avLst/>
+          </a:prstGeom>
+          <a:noFill/>
+        </p:spPr>
+        <p:txBody>
+          <a:bodyPr wrap="square" lIns="45720" rIns="45720" tIns="18288" bIns="18288" anchor="t">
+            <a:noAutofit/>
+          </a:bodyPr>
+          <a:lstStyle/>
+          <a:p>
+            <a:pPr algn="l"/>
+            <a:r>
+              <a:rPr sz="1400" b="0">
+                <a:solidFill>
+                  <a:srgbClr val="335B74"/>
+                </a:solidFill>
+                <a:latin typeface="Calibri"/>
+              </a:rPr>
+              <a:t>About 1.5 seconds per run</a:t>
+            </a:r>
+          </a:p>
+        </p:txBody>
+      </p:sp>
+      <p:sp>
+        <p:nvSpPr>
+          <p:cNvPr id="46" name="Quality tile 4"/>
+          <p:cNvSpPr/>
+          <p:nvPr/>
+        </p:nvSpPr>
+        <p:spPr>
+          <a:xfrm>
+            <a:off x="7818120" y="4389120"/>
+            <a:ext cx="3886200" cy="749808"/>
+          </a:xfrm>
+          <a:prstGeom prst="roundRect">
+            <a:avLst>
+              <a:gd name="adj" fmla="val 10000"/>
+            </a:avLst>
+          </a:prstGeom>
+          <a:solidFill>
+            <a:srgbClr val="FBEFE3"/>
+          </a:solidFill>
+          <a:ln>
+            <a:noFill/>
+          </a:ln>
+          <a:effectLst/>
+        </p:spPr>
+        <p:style>
+          <a:lnRef idx="1">
+            <a:schemeClr val="accent1"/>
+          </a:lnRef>
+          <a:fillRef idx="3">
+            <a:schemeClr val="accent1"/>
+          </a:fillRef>
+          <a:effectRef idx="2">
+            <a:schemeClr val="accent1"/>
+          </a:effectRef>
+          <a:fontRef idx="minor">
+            <a:schemeClr val="lt1"/>
+          </a:fontRef>
+        </p:style>
+        <p:txBody>
+          <a:bodyPr rtlCol="0" anchor="ctr"/>
+          <a:lstStyle/>
+          <a:p>
+            <a:pPr algn="ctr"/>
+          </a:p>
+        </p:txBody>
+      </p:sp>
+      <p:sp>
+        <p:nvSpPr>
+          <p:cNvPr id="47" name="Oval 46"/>
+          <p:cNvSpPr/>
+          <p:nvPr/>
+        </p:nvSpPr>
+        <p:spPr>
+          <a:xfrm>
+            <a:off x="7973568" y="4581144"/>
+            <a:ext cx="365760" cy="365760"/>
+          </a:xfrm>
+          <a:prstGeom prst="ellipse">
+            <a:avLst/>
+          </a:prstGeom>
+          <a:solidFill>
+            <a:srgbClr val="D9731A"/>
+          </a:solidFill>
+          <a:ln>
+            <a:noFill/>
+          </a:ln>
+          <a:effectLst/>
+        </p:spPr>
+        <p:style>
+          <a:lnRef idx="1">
+            <a:schemeClr val="accent1"/>
+          </a:lnRef>
+          <a:fillRef idx="3">
+            <a:schemeClr val="accent1"/>
+          </a:fillRef>
+          <a:effectRef idx="2">
+            <a:schemeClr val="accent1"/>
+          </a:effectRef>
+          <a:fontRef idx="minor">
+            <a:schemeClr val="lt1"/>
+          </a:fontRef>
+        </p:style>
+        <p:txBody>
+          <a:bodyPr rtlCol="0" anchor="ctr"/>
+          <a:lstStyle/>
+          <a:p>
+            <a:pPr algn="ctr"/>
+          </a:p>
+        </p:txBody>
+      </p:sp>
+      <p:sp>
+        <p:nvSpPr>
+          <p:cNvPr id="48" name="TextBox 47"/>
+          <p:cNvSpPr txBox="1"/>
+          <p:nvPr/>
+        </p:nvSpPr>
+        <p:spPr>
+          <a:xfrm>
+            <a:off x="8503920" y="4443983"/>
+            <a:ext cx="3108960" cy="365760"/>
+          </a:xfrm>
+          <a:prstGeom prst="rect">
+            <a:avLst/>
+          </a:prstGeom>
+          <a:noFill/>
+        </p:spPr>
+        <p:txBody>
+          <a:bodyPr wrap="square" lIns="45720" rIns="45720" tIns="18288" bIns="18288" anchor="t">
+            <a:noAutofit/>
+          </a:bodyPr>
+          <a:lstStyle/>
+          <a:p>
+            <a:pPr algn="l"/>
+            <a:r>
+              <a:rPr sz="1800" b="1">
+                <a:solidFill>
+                  <a:srgbClr val="335B74"/>
+                </a:solidFill>
+                <a:latin typeface="Calibri"/>
+              </a:rPr>
+              <a:t>Safe inputs</a:t>
+            </a:r>
+          </a:p>
+        </p:txBody>
+      </p:sp>
+      <p:sp>
+        <p:nvSpPr>
+          <p:cNvPr id="49" name="TextBox 48"/>
+          <p:cNvSpPr txBox="1"/>
+          <p:nvPr/>
+        </p:nvSpPr>
+        <p:spPr>
+          <a:xfrm>
+            <a:off x="8503920" y="4791456"/>
+            <a:ext cx="3108960" cy="320040"/>
+          </a:xfrm>
+          <a:prstGeom prst="rect">
+            <a:avLst/>
+          </a:prstGeom>
+          <a:noFill/>
+        </p:spPr>
+        <p:txBody>
+          <a:bodyPr wrap="square" lIns="45720" rIns="45720" tIns="18288" bIns="18288" anchor="t">
+            <a:noAutofit/>
+          </a:bodyPr>
+          <a:lstStyle/>
+          <a:p>
+            <a:pPr algn="l"/>
+            <a:r>
+              <a:rPr sz="1400" b="0">
+                <a:solidFill>
+                  <a:srgbClr val="335B74"/>
+                </a:solidFill>
+                <a:latin typeface="Calibri"/>
+              </a:rPr>
+              <a:t>Bounded and escaped</a:t>
+            </a:r>
+          </a:p>
+        </p:txBody>
+      </p:sp>
+      <p:sp>
+        <p:nvSpPr>
+          <p:cNvPr id="50" name="TextBox 49"/>
+          <p:cNvSpPr txBox="1"/>
+          <p:nvPr/>
+        </p:nvSpPr>
+        <p:spPr>
+          <a:xfrm>
+            <a:off x="594360" y="5349240"/>
+            <a:ext cx="2011680" cy="411480"/>
+          </a:xfrm>
+          <a:prstGeom prst="rect">
+            <a:avLst/>
+          </a:prstGeom>
+          <a:noFill/>
+        </p:spPr>
+        <p:txBody>
+          <a:bodyPr wrap="square" lIns="45720" rIns="45720" tIns="18288" bIns="18288" anchor="ctr">
+            <a:noAutofit/>
+          </a:bodyPr>
+          <a:lstStyle/>
+          <a:p>
+            <a:pPr algn="l"/>
+            <a:r>
+              <a:rPr sz="1600" b="1">
                 <a:solidFill>
                   <a:srgbClr val="2683C6"/>
                 </a:solidFill>
@@ -22885,14 +25172,14 @@
       </p:sp>
       <p:sp>
         <p:nvSpPr>
-          <p:cNvPr id="18" name="Rounded Rectangle 17"/>
+          <p:cNvPr id="51" name="Rounded Rectangle 50"/>
           <p:cNvSpPr/>
           <p:nvPr/>
         </p:nvSpPr>
         <p:spPr>
           <a:xfrm>
-            <a:off x="594360" y="4389120"/>
-            <a:ext cx="1737360" cy="502920"/>
+            <a:off x="2377440" y="5349240"/>
+            <a:ext cx="1417320" cy="411480"/>
           </a:xfrm>
           <a:prstGeom prst="roundRect">
             <a:avLst>
@@ -22924,14 +25211,12 @@
           </a:fontRef>
         </p:style>
         <p:txBody>
-          <a:bodyPr rtlCol="0" anchor="ctr" wrap="square" tIns="36576" bIns="36576">
-            <a:noAutofit/>
-          </a:bodyPr>
+          <a:bodyPr rtlCol="0" anchor="ctr" lIns="73152" rIns="73152"/>
           <a:lstStyle/>
           <a:p>
             <a:pPr algn="ctr"/>
             <a:r>
-              <a:rPr sz="1500" b="0" i="0">
+              <a:rPr sz="1400">
                 <a:solidFill>
                   <a:srgbClr val="335B74"/>
                 </a:solidFill>
@@ -22944,14 +25229,14 @@
       </p:sp>
       <p:sp>
         <p:nvSpPr>
-          <p:cNvPr id="19" name="Rounded Rectangle 18"/>
+          <p:cNvPr id="52" name="Rounded Rectangle 51"/>
           <p:cNvSpPr/>
           <p:nvPr/>
         </p:nvSpPr>
         <p:spPr>
           <a:xfrm>
-            <a:off x="2441448" y="4389120"/>
-            <a:ext cx="1280160" cy="502920"/>
+            <a:off x="3886200" y="5349240"/>
+            <a:ext cx="1005840" cy="411480"/>
           </a:xfrm>
           <a:prstGeom prst="roundRect">
             <a:avLst>
@@ -22983,14 +25268,12 @@
           </a:fontRef>
         </p:style>
         <p:txBody>
-          <a:bodyPr rtlCol="0" anchor="ctr" wrap="square" tIns="36576" bIns="36576">
-            <a:noAutofit/>
-          </a:bodyPr>
+          <a:bodyPr rtlCol="0" anchor="ctr" lIns="73152" rIns="73152"/>
           <a:lstStyle/>
           <a:p>
             <a:pPr algn="ctr"/>
             <a:r>
-              <a:rPr sz="1500" b="0" i="0">
+              <a:rPr sz="1400">
                 <a:solidFill>
                   <a:srgbClr val="335B74"/>
                 </a:solidFill>
@@ -23003,14 +25286,14 @@
       </p:sp>
       <p:sp>
         <p:nvSpPr>
-          <p:cNvPr id="20" name="Rounded Rectangle 19"/>
+          <p:cNvPr id="53" name="Rounded Rectangle 52"/>
           <p:cNvSpPr/>
           <p:nvPr/>
         </p:nvSpPr>
         <p:spPr>
           <a:xfrm>
-            <a:off x="3831335" y="4389120"/>
-            <a:ext cx="1280160" cy="502920"/>
+            <a:off x="4983480" y="5349240"/>
+            <a:ext cx="1005840" cy="411480"/>
           </a:xfrm>
           <a:prstGeom prst="roundRect">
             <a:avLst>
@@ -23042,14 +25325,12 @@
           </a:fontRef>
         </p:style>
         <p:txBody>
-          <a:bodyPr rtlCol="0" anchor="ctr" wrap="square" tIns="36576" bIns="36576">
-            <a:noAutofit/>
-          </a:bodyPr>
+          <a:bodyPr rtlCol="0" anchor="ctr" lIns="73152" rIns="73152"/>
           <a:lstStyle/>
           <a:p>
             <a:pPr algn="ctr"/>
             <a:r>
-              <a:rPr sz="1500" b="0" i="0">
+              <a:rPr sz="1400">
                 <a:solidFill>
                   <a:srgbClr val="335B74"/>
                 </a:solidFill>
@@ -23062,14 +25343,14 @@
       </p:sp>
       <p:sp>
         <p:nvSpPr>
-          <p:cNvPr id="21" name="Rounded Rectangle 20"/>
+          <p:cNvPr id="54" name="Rounded Rectangle 53"/>
           <p:cNvSpPr/>
           <p:nvPr/>
         </p:nvSpPr>
         <p:spPr>
           <a:xfrm>
-            <a:off x="5221224" y="4389120"/>
-            <a:ext cx="1554480" cy="502920"/>
+            <a:off x="6080760" y="5349240"/>
+            <a:ext cx="1280160" cy="411480"/>
           </a:xfrm>
           <a:prstGeom prst="roundRect">
             <a:avLst>
@@ -23101,14 +25382,12 @@
           </a:fontRef>
         </p:style>
         <p:txBody>
-          <a:bodyPr rtlCol="0" anchor="ctr" wrap="square" tIns="36576" bIns="36576">
-            <a:noAutofit/>
-          </a:bodyPr>
+          <a:bodyPr rtlCol="0" anchor="ctr" lIns="73152" rIns="73152"/>
           <a:lstStyle/>
           <a:p>
             <a:pPr algn="ctr"/>
             <a:r>
-              <a:rPr sz="1500" b="0" i="0">
+              <a:rPr sz="1400">
                 <a:solidFill>
                   <a:srgbClr val="335B74"/>
                 </a:solidFill>
@@ -23121,14 +25400,14 @@
       </p:sp>
       <p:sp>
         <p:nvSpPr>
-          <p:cNvPr id="22" name="Rounded Rectangle 21"/>
+          <p:cNvPr id="55" name="Rounded Rectangle 54"/>
           <p:cNvSpPr/>
           <p:nvPr/>
         </p:nvSpPr>
         <p:spPr>
           <a:xfrm>
-            <a:off x="6885431" y="4389120"/>
-            <a:ext cx="1188720" cy="502920"/>
+            <a:off x="7452360" y="5349240"/>
+            <a:ext cx="960120" cy="411480"/>
           </a:xfrm>
           <a:prstGeom prst="roundRect">
             <a:avLst>
@@ -23160,14 +25439,12 @@
           </a:fontRef>
         </p:style>
         <p:txBody>
-          <a:bodyPr rtlCol="0" anchor="ctr" wrap="square" tIns="36576" bIns="36576">
-            <a:noAutofit/>
-          </a:bodyPr>
+          <a:bodyPr rtlCol="0" anchor="ctr" lIns="73152" rIns="73152"/>
           <a:lstStyle/>
           <a:p>
             <a:pPr algn="ctr"/>
             <a:r>
-              <a:rPr sz="1500" b="0" i="0">
+              <a:rPr sz="1400">
                 <a:solidFill>
                   <a:srgbClr val="335B74"/>
                 </a:solidFill>
@@ -23180,14 +25457,14 @@
       </p:sp>
       <p:sp>
         <p:nvSpPr>
-          <p:cNvPr id="23" name="Rounded Rectangle 22"/>
+          <p:cNvPr id="56" name="Rounded Rectangle 55"/>
           <p:cNvSpPr/>
           <p:nvPr/>
         </p:nvSpPr>
         <p:spPr>
           <a:xfrm>
-            <a:off x="8183879" y="4389120"/>
-            <a:ext cx="1188720" cy="502920"/>
+            <a:off x="8503920" y="5349240"/>
+            <a:ext cx="960120" cy="411480"/>
           </a:xfrm>
           <a:prstGeom prst="roundRect">
             <a:avLst>
@@ -23219,14 +25496,12 @@
           </a:fontRef>
         </p:style>
         <p:txBody>
-          <a:bodyPr rtlCol="0" anchor="ctr" wrap="square" tIns="36576" bIns="36576">
-            <a:noAutofit/>
-          </a:bodyPr>
+          <a:bodyPr rtlCol="0" anchor="ctr" lIns="73152" rIns="73152"/>
           <a:lstStyle/>
           <a:p>
             <a:pPr algn="ctr"/>
             <a:r>
-              <a:rPr sz="1500" b="0" i="0">
+              <a:rPr sz="1400">
                 <a:solidFill>
                   <a:srgbClr val="335B74"/>
                 </a:solidFill>
@@ -23239,14 +25514,14 @@
       </p:sp>
       <p:sp>
         <p:nvSpPr>
-          <p:cNvPr id="24" name="Rounded Rectangle 23"/>
+          <p:cNvPr id="57" name="Rounded Rectangle 56"/>
           <p:cNvSpPr/>
           <p:nvPr/>
         </p:nvSpPr>
         <p:spPr>
           <a:xfrm>
-            <a:off x="9482328" y="4389120"/>
-            <a:ext cx="2011680" cy="502920"/>
+            <a:off x="9555480" y="5349240"/>
+            <a:ext cx="1645920" cy="411480"/>
           </a:xfrm>
           <a:prstGeom prst="roundRect">
             <a:avLst>
@@ -23278,101 +25553,53 @@
           </a:fontRef>
         </p:style>
         <p:txBody>
-          <a:bodyPr rtlCol="0" anchor="ctr" wrap="square" tIns="36576" bIns="36576">
+          <a:bodyPr rtlCol="0" anchor="ctr" lIns="73152" rIns="73152"/>
+          <a:lstStyle/>
+          <a:p>
+            <a:pPr algn="ctr"/>
+            <a:r>
+              <a:rPr sz="1400">
+                <a:solidFill>
+                  <a:srgbClr val="335B74"/>
+                </a:solidFill>
+                <a:latin typeface="Calibri"/>
+              </a:rPr>
+              <a:t>Browser canvas</a:t>
+            </a:r>
+          </a:p>
+        </p:txBody>
+      </p:sp>
+      <p:sp>
+        <p:nvSpPr>
+          <p:cNvPr id="58" name="TextBox 57"/>
+          <p:cNvSpPr txBox="1"/>
+          <p:nvPr/>
+        </p:nvSpPr>
+        <p:spPr>
+          <a:xfrm>
+            <a:off x="594360" y="5852160"/>
+            <a:ext cx="10972800" cy="320040"/>
+          </a:xfrm>
+          <a:prstGeom prst="rect">
+            <a:avLst/>
+          </a:prstGeom>
+          <a:noFill/>
+        </p:spPr>
+        <p:txBody>
+          <a:bodyPr wrap="square" lIns="45720" rIns="45720" tIns="18288" bIns="18288" anchor="t">
             <a:noAutofit/>
           </a:bodyPr>
           <a:lstStyle/>
           <a:p>
-            <a:pPr algn="ctr"/>
-            <a:r>
-              <a:rPr sz="1500" b="0" i="0">
-                <a:solidFill>
-                  <a:srgbClr val="335B74"/>
-                </a:solidFill>
-                <a:latin typeface="Calibri"/>
-              </a:rPr>
-              <a:t>Browser canvas</a:t>
-            </a:r>
-          </a:p>
-        </p:txBody>
-      </p:sp>
-      <p:sp>
-        <p:nvSpPr>
-          <p:cNvPr id="25" name="Performance"/>
-          <p:cNvSpPr/>
-          <p:nvPr/>
-        </p:nvSpPr>
-        <p:spPr>
-          <a:xfrm>
-            <a:off x="594360" y="5212080"/>
-            <a:ext cx="11109960" cy="777240"/>
-          </a:xfrm>
-          <a:prstGeom prst="roundRect">
-            <a:avLst>
-              <a:gd name="adj" fmla="val 8000"/>
-            </a:avLst>
-          </a:prstGeom>
-          <a:solidFill>
-            <a:srgbClr val="EAF3FA"/>
-          </a:solidFill>
-          <a:ln>
-            <a:noFill/>
-          </a:ln>
-          <a:effectLst/>
-        </p:spPr>
-        <p:style>
-          <a:lnRef idx="1">
-            <a:schemeClr val="accent1"/>
-          </a:lnRef>
-          <a:fillRef idx="3">
-            <a:schemeClr val="accent1"/>
-          </a:fillRef>
-          <a:effectRef idx="2">
-            <a:schemeClr val="accent1"/>
-          </a:effectRef>
-          <a:fontRef idx="minor">
-            <a:schemeClr val="lt1"/>
-          </a:fontRef>
-        </p:style>
-        <p:txBody>
-          <a:bodyPr rtlCol="0" anchor="ctr"/>
-          <a:lstStyle/>
-          <a:p>
-            <a:pPr algn="ctr"/>
-          </a:p>
-        </p:txBody>
-      </p:sp>
-      <p:sp>
-        <p:nvSpPr>
-          <p:cNvPr id="26" name="TextBox 25"/>
-          <p:cNvSpPr txBox="1"/>
-          <p:nvPr/>
-        </p:nvSpPr>
-        <p:spPr>
-          <a:xfrm>
-            <a:off x="777240" y="5257800"/>
-            <a:ext cx="10789920" cy="685800"/>
-          </a:xfrm>
-          <a:prstGeom prst="rect">
-            <a:avLst/>
-          </a:prstGeom>
-          <a:noFill/>
-        </p:spPr>
-        <p:txBody>
-          <a:bodyPr wrap="square" lIns="45720" rIns="45720" tIns="27432" bIns="27432" anchor="ctr">
-            <a:noAutofit/>
-          </a:bodyPr>
-          <a:lstStyle/>
-          <a:p>
-            <a:pPr algn="ctr"/>
-            <a:r>
-              <a:rPr sz="2000" b="1" i="0">
-                <a:solidFill>
-                  <a:srgbClr val="335B74"/>
-                </a:solidFill>
-                <a:latin typeface="Calibri"/>
-              </a:rPr>
-              <a:t>Default run: 100 individuals, 150 iterations, 20 assets finishes in about 1.5 seconds</a:t>
+            <a:pPr algn="l"/>
+            <a:r>
+              <a:rPr sz="1300" b="0">
+                <a:solidFill>
+                  <a:srgbClr val="8A97A8"/>
+                </a:solidFill>
+                <a:latin typeface="Calibri"/>
+              </a:rPr>
+              <a:t>All open source: zero software cost</a:t>
             </a:r>
           </a:p>
         </p:txBody>

</xml_diff>